<commit_message>
Layout: question beside the title at 1440, compact question above the commentary on mobile, commentary in three paragraphs
</commit_message>
<xml_diff>
--- a/exports/lowther-august-2026-commentary.pptx
+++ b/exports/lowther-august-2026-commentary.pptx
@@ -1019,7 +1019,53 @@
                 <a:ea typeface="Georgia" pitchFamily="34" charset="-122"/>
                 <a:cs typeface="Georgia" pitchFamily="34" charset="-120"/>
               </a:rPr>
-              <a:t>Revenue for August came in at £200,000, above budget by £10,000 (5.3%) and up on last year by £30,000 (17.6%), while gross profit of £68,000 was below budget by £4,200 (5.8%) as gross margin slipped to 34.0%, down 4.0 percentage points against budget. Operating profit for August was £17,500, below budget by £2,700 (13.4%) and slightly down on last year by £250 (1.4%). Year to date the picture is stronger, with revenue of £960,000 above budget by £10,000 (1.1%) and up on last year by £115,000 (13.6%), and operating profit of £111,000 above budget by £10,000 (9.9%) and up on last year by £34,125 (44.4%). On clients, Orchard Lane Foods remained the largest account at 31.0% of August revenue, with its month's revenue of £62,000 above its May to July average by £4,333 (7.5%). Marlow &amp; Finch's August revenue of £18,000 was notably below its May to July average by £12,000 (40.0%), and its share of year-to-date revenue at 14.4% is worth watching alongside the other client movements this month.</a:t>
+              <a:t>Revenue for August came in at £200,000, above budget by £10,000 (5.3%) and up on last year by £30,000 (17.6%), while gross profit of £68,000 was below budget by £4,200 (5.8%) as gross margin slipped to 34.0%, down 4.0 percentage points against budget. Operating profit for August was £17,500, below budget by £2,700 (13.4%) and slightly down on last year by £250 (1.4%).</a:t>
+            </a:r>
+            <a:endParaRPr lang="en-US" sz="1300" dirty="0"/>
+          </a:p>
+          <a:p>
+            <a:pPr indent="0" marL="0">
+              <a:lnSpc>
+                <a:spcPct val="115000"/>
+              </a:lnSpc>
+              <a:spcAft>
+                <a:spcPts val="600"/>
+              </a:spcAft>
+              <a:buNone/>
+            </a:pPr>
+            <a:r>
+              <a:rPr lang="en-US" sz="1300" dirty="0">
+                <a:solidFill>
+                  <a:srgbClr val="1E2A3A"/>
+                </a:solidFill>
+                <a:latin typeface="Georgia" pitchFamily="34" charset="0"/>
+                <a:ea typeface="Georgia" pitchFamily="34" charset="-122"/>
+                <a:cs typeface="Georgia" pitchFamily="34" charset="-120"/>
+              </a:rPr>
+              <a:t>Year to date the picture is stronger, with revenue of £960,000 above budget by £10,000 (1.1%) and up on last year by £115,000 (13.6%), and operating profit of £111,000 above budget by £10,000 (9.9%) and up on last year by £34,125 (44.4%).</a:t>
+            </a:r>
+            <a:endParaRPr lang="en-US" sz="1300" dirty="0"/>
+          </a:p>
+          <a:p>
+            <a:pPr indent="0" marL="0">
+              <a:lnSpc>
+                <a:spcPct val="115000"/>
+              </a:lnSpc>
+              <a:spcAft>
+                <a:spcPts val="600"/>
+              </a:spcAft>
+              <a:buNone/>
+            </a:pPr>
+            <a:r>
+              <a:rPr lang="en-US" sz="1300" dirty="0">
+                <a:solidFill>
+                  <a:srgbClr val="1E2A3A"/>
+                </a:solidFill>
+                <a:latin typeface="Georgia" pitchFamily="34" charset="0"/>
+                <a:ea typeface="Georgia" pitchFamily="34" charset="-122"/>
+                <a:cs typeface="Georgia" pitchFamily="34" charset="-120"/>
+              </a:rPr>
+              <a:t>On clients, Orchard Lane Foods remained the largest account at 31.0% of August revenue, with its month's revenue of £62,000 above its May to July average by £4,333 (7.5%). Marlow &amp; Finch's August revenue of £18,000 was notably below its May to July average by £12,000 (40.0%), and its share of year-to-date revenue at 14.4% is worth watching alongside the other client movements this month.</a:t>
             </a:r>
             <a:endParaRPr lang="en-US" sz="1300" dirty="0"/>
           </a:p>

</xml_diff>

<commit_message>
Checker v3 after a fresh review: rankings, relations, judgements, negations, other months and uncalculated measures never ticked; release gate counts review points in failing sentences; slide table widened with sentence markers; payroll input dated before the snapshot; figures fingerprint from the drafted facts; other questions beside the commentary; mobile figures reflow; fixture ids fixed; no absolute paths
</commit_message>
<xml_diff>
--- a/exports/lowther-august-2026-commentary.pptx
+++ b/exports/lowther-august-2026-commentary.pptx
@@ -503,40 +503,13 @@
             <a:r>
               <a:rPr lang="en-US" dirty="0"/>
               <a:t>Draft: Draft B, written for the snapshot with the approved accrual (run 2 of 10, claude-sonnet-5, 2026-09-28).
-Evidence for each figure:
-[1] £200,000: Revenue, August 2026. report section total. Source: xero_pl_2026-08.json. Metric revenue.month.actual, snapshot c952e4151e561d66.
-[2] £10,000: Revenue, August 2026, difference against budget. actual minus budget. Source: xero_pl_2026-08.json; xero_budget.json. Metric revenue.month.vs_budget, snapshot c952e4151e561d66.
-[3] 5.3%: Revenue, August 2026, % change against budget. (actual - budget) / budget. Source: xero_pl_2026-08.json; xero_budget.json. Metric revenue.month.vs_budget_pct, snapshot c952e4151e561d66.
-[4] £30,000: Revenue, August 2026, difference against prior year. actual minus prior year. Source: xero_pl_2026-08.json; xero_pl_2025-08.json. Metric revenue.month.vs_py, snapshot c952e4151e561d66.
-[5] 17.6%: Revenue, August 2026, % change against prior year. (actual - prior year) / prior year. Source: xero_pl_2026-08.json; xero_pl_2025-08.json. Metric revenue.month.vs_py_pct, snapshot c952e4151e561d66.
-[6] £68,000: Gross profit, August 2026. revenue £200,000 - direct costs £132,000. Source: xero_pl_2026-08.json; approved adjustment accrual-aug-payroll. Metric gross_profit.month.actual, snapshot c952e4151e561d66.
-[7] £4,200: Gross profit, August 2026, difference against budget. actual minus budget. Source: approved adjustment accrual-aug-payroll; xero_pl_2026-08.json; xero_budget.json. Metric gross_profit.month.vs_budget, snapshot c952e4151e561d66.
-[8] 5.8%: Gross profit, August 2026, % change against budget. (actual - budget) / budget. Source: approved adjustment accrual-aug-payroll; xero_pl_2026-08.json; xero_budget.json. Metric gross_profit.month.vs_budget_pct, snapshot c952e4151e561d66.
-[9] 34.0%: Gross margin, August 2026. gross profit £68,000 / revenue £200,000. Source: xero_pl_2026-08.json; approved adjustment accrual-aug-payroll. Metric gross_margin.month.actual, snapshot c952e4151e561d66.
-[10] 4.0 percentage points: Gross margin, August 2026, difference against budget. actual margin minus budget margin, unrounded. Source: approved adjustment accrual-aug-payroll; xero_pl_2026-08.json; xero_budget.json. Metric gross_margin.month.vs_budget_pp, snapshot c952e4151e561d66.
-[11] £17,500: Operating profit, August 2026. gross profit £68,000 - overheads £50,500. Source: xero_pl_2026-08.json; approved adjustment accrual-aug-payroll. Metric operating_profit.month.actual, snapshot c952e4151e561d66.
-[12] £2,700: Operating profit, August 2026, difference against budget. actual minus budget. Source: approved adjustment accrual-aug-payroll; xero_pl_2026-08.json; xero_budget.json. Metric operating_profit.month.vs_budget, snapshot c952e4151e561d66.
-[13] 13.4%: Operating profit, August 2026, % change against budget. (actual - budget) / budget. Source: approved adjustment accrual-aug-payroll; xero_pl_2026-08.json; xero_budget.json. Metric operating_profit.month.vs_budget_pct, snapshot c952e4151e561d66.
-[14] £250: Operating profit, August 2026, difference against prior year. actual minus prior year. Source: approved adjustment accrual-aug-payroll; xero_pl_2026-08.json; xero_pl_2025-08.json. Metric operating_profit.month.vs_py, snapshot c952e4151e561d66.
-[15] 1.4%: Operating profit, August 2026, % change against prior year. (actual - prior year) / prior year. Source: approved adjustment accrual-aug-payroll; xero_pl_2026-08.json; xero_pl_2025-08.json. Metric operating_profit.month.vs_py_pct, snapshot c952e4151e561d66.
-[16] £960,000: Revenue, year to date, 1 April to 31 August 2026. report section total. Source: xero_pl_ytd_2026-04_2026-08.json. Metric revenue.ytd.actual, snapshot c952e4151e561d66.
-[17] £10,000: Revenue, year to date, 1 April to 31 August 2026, difference against budget. actual minus budget. Source: xero_pl_ytd_2026-04_2026-08.json; xero_budget.json. Metric revenue.ytd.vs_budget, snapshot c952e4151e561d66.
-[18] 1.1%: Revenue, year to date, 1 April to 31 August 2026, % change against budget. (actual - budget) / budget. Source: xero_pl_ytd_2026-04_2026-08.json; xero_budget.json. Metric revenue.ytd.vs_budget_pct, snapshot c952e4151e561d66.
-[19] £115,000: Revenue, year to date, 1 April to 31 August 2026, difference against prior year. actual minus prior year. Source: xero_pl_ytd_2026-04_2026-08.json; xero_pl_ytd_2025-04_2025-08.json. Metric revenue.ytd.vs_py, snapshot c952e4151e561d66.
-[20] 13.6%: Revenue, year to date, 1 April to 31 August 2026, % change against prior year. (actual - prior year) / prior year. Source: xero_pl_ytd_2026-04_2026-08.json; xero_pl_ytd_2025-04_2025-08.json. Metric revenue.ytd.vs_py_pct, snapshot c952e4151e561d66.
-[21] £111,000: Operating profit, year to date, 1 April to 31 August 2026. gross profit £365,000 - overheads £254,000. Source: xero_pl_ytd_2026-04_2026-08.json; approved adjustment accrual-aug-payroll. Metric operating_profit.ytd.actual, snapshot c952e4151e561d66.
-[22] £10,000: Operating profit, year to date, 1 April to 31 August 2026, difference against budget. actual minus budget. Source: approved adjustment accrual-aug-payroll; xero_pl_ytd_2026-04_2026-08.json; xero_budget.json. Metric operating_profit.ytd.vs_budget, snapshot c952e4151e561d66.
-[23] 9.9%: Operating profit, year to date, 1 April to 31 August 2026, % change against budget. (actual - budget) / budget. Source: approved adjustment accrual-aug-payroll; xero_pl_ytd_2026-04_2026-08.json; xero_budget.json. Metric operating_profit.ytd.vs_budget_pct, snapshot c952e4151e561d66.
-[24] £34,125: Operating profit, year to date, 1 April to 31 August 2026, difference against prior year. actual minus prior year. Source: approved adjustment accrual-aug-payroll; xero_pl_ytd_2026-04_2026-08.json; xero_pl_ytd_2025-04_2025-08.json. Metric operating_profit.ytd.vs_py, snapshot c952e4151e561d66.
-[25] 44.4%: Operating profit, year to date, 1 April to 31 August 2026, % change against prior year. (actual - prior year) / prior year. Source: approved adjustment accrual-aug-payroll; xero_pl_ytd_2026-04_2026-08.json; xero_pl_ytd_2025-04_2025-08.json. Metric operating_profit.ytd.vs_py_pct, snapshot c952e4151e561d66.
-[26] 31.0%: Orchard Lane Foods: share of agency revenue, August 2026. client revenue / agency revenue. Source: xero_pl_by_client_2026-08.json; xero_pl_2026-08.json. Metric client.orchard-lane.share.month.actual, snapshot c952e4151e561d66.
-[27] £62,000: Orchard Lane Foods: revenue, August 2026. Income, Client column. Source: xero_pl_by_client_2026-08.json. Metric client.orchard-lane.revenue.month.actual, snapshot c952e4151e561d66.
-[28] £4,333: Orchard Lane Foods: revenue, August 2026 against its May to July average, difference. August minus three-month average. Source: xero_pl_by_client_2026-08.json. Metric client.orchard-lane.revenue.month.vs_avg3m, snapshot c952e4151e561d66.
-[29] 7.5%: Orchard Lane Foods: revenue, August 2026 against its May to July average, % change. (August - average) / average. Source: xero_pl_by_client_2026-08.json. Metric client.orchard-lane.revenue.month.vs_avg3m_pct, snapshot c952e4151e561d66.
-[30] £18,000: Marlow &amp; Finch: revenue, August 2026. Income, Client column. Source: xero_pl_by_client_2026-08.json. Metric client.marlow-finch.revenue.month.actual, snapshot c952e4151e561d66.
-[31] £12,000: Marlow &amp; Finch: revenue, August 2026 against its May to July average, difference. August minus three-month average. Source: xero_pl_by_client_2026-08.json. Metric client.marlow-finch.revenue.month.vs_avg3m, snapshot c952e4151e561d66.
-[32] 40.0%: Marlow &amp; Finch: revenue, August 2026 against its May to July average, % change. (August - average) / average. Source: xero_pl_by_client_2026-08.json. Metric client.marlow-finch.revenue.month.vs_avg3m_pct, snapshot c952e4151e561d66.
-[33] 14.4%: Marlow &amp; Finch: share of agency revenue, year to date. client revenue / agency revenue. Source: xero_pl_by_client_ytd_2026.json; xero_pl_ytd_2026-04_2026-08.json. Metric client.marlow-finch.share.ytd.actual, snapshot c952e4151e561d66.</a:t>
+Figures fingerprint e07356b8a0bce5fe.
+Evidence, by sentence:
+[1] £200,000 = Revenue, August 2026; report section total; source xero_pl_2026-08.json; metric revenue.month.actual | £10,000 = Revenue, August 2026, difference against budget; actual minus budget; source xero_pl_2026-08.json, xero_budget.json; metric revenue.month.vs_budget | 5.3% = Revenue, August 2026, % change against budget; (actual - budget) / budget; source xero_pl_2026-08.json, xero_budget.json; metric revenue.month.vs_budget_pct | £30,000 = Revenue, August 2026, difference against prior year; actual minus prior year; source xero_pl_2026-08.json, xero_pl_2025-08.json; metric revenue.month.vs_py | 17.6% = Revenue, August 2026, % change against prior year; (actual - prior year) / prior year; source xero_pl_2026-08.json, xero_pl_2025-08.json; metric revenue.month.vs_py_pct | £68,000 = Gross profit, August 2026; revenue £200,000 - direct costs £132,000; source xero_pl_2026-08.json, approved adjustment accrual-aug-payroll; metric gross_profit.month.actual | £4,200 = Gross profit, August 2026, difference against budget; actual minus budget; source approved adjustment accrual-aug-payroll, xero_pl_2026-08.json, xero_budget.json; metric gross_profit.month.vs_budget | 5.8% = Gross profit, August 2026, % change against budget; (actual - budget) / budget; source approved adjustment accrual-aug-payroll, xero_pl_2026-08.json, xero_budget.json; metric gross_profit.month.vs_budget_pct | 34.0% = Gross margin, August 2026; gross profit £68,000 / revenue £200,000; source xero_pl_2026-08.json, approved adjustment accrual-aug-payroll; metric gross_margin.month.actual | 4.0 percentage points = Gross margin, August 2026, difference against budget; actual margin minus budget margin, unrounded; source approved adjustment accrual-aug-payroll, xero_pl_2026-08.json, xero_budget.json; metric gross_margin.month.vs_budget_pp
+[2] £17,500 = Operating profit, August 2026; gross profit £68,000 - overheads £50,500; source xero_pl_2026-08.json, approved adjustment accrual-aug-payroll; metric operating_profit.month.actual | £2,700 = Operating profit, August 2026, difference against budget; actual minus budget; source approved adjustment accrual-aug-payroll, xero_pl_2026-08.json, xero_budget.json; metric operating_profit.month.vs_budget | 13.4% = Operating profit, August 2026, % change against budget; (actual - budget) / budget; source approved adjustment accrual-aug-payroll, xero_pl_2026-08.json, xero_budget.json; metric operating_profit.month.vs_budget_pct | £250 = Operating profit, August 2026, difference against prior year; actual minus prior year; source approved adjustment accrual-aug-payroll, xero_pl_2026-08.json, xero_pl_2025-08.json; metric operating_profit.month.vs_py | 1.4% = Operating profit, August 2026, % change against prior year; (actual - prior year) / prior year; source approved adjustment accrual-aug-payroll, xero_pl_2026-08.json, xero_pl_2025-08.json; metric operating_profit.month.vs_py_pct
+[3] £960,000 = Revenue, year to date, 1 April to 31 August 2026; report section total; source xero_pl_ytd_2026-04_2026-08.json; metric revenue.ytd.actual | £10,000 = Revenue, year to date, 1 April to 31 August 2026, difference against budget; actual minus budget; source xero_pl_ytd_2026-04_2026-08.json, xero_budget.json; metric revenue.ytd.vs_budget | 1.1% = Revenue, year to date, 1 April to 31 August 2026, % change against budget; (actual - budget) / budget; source xero_pl_ytd_2026-04_2026-08.json, xero_budget.json; metric revenue.ytd.vs_budget_pct | £115,000 = Revenue, year to date, 1 April to 31 August 2026, difference against prior year; actual minus prior year; source xero_pl_ytd_2026-04_2026-08.json, xero_pl_ytd_2025-04_2025-08.json; metric revenue.ytd.vs_py | 13.6% = Revenue, year to date, 1 April to 31 August 2026, % change against prior year; (actual - prior year) / prior year; source xero_pl_ytd_2026-04_2026-08.json, xero_pl_ytd_2025-04_2025-08.json; metric revenue.ytd.vs_py_pct | £111,000 = Operating profit, year to date, 1 April to 31 August 2026; gross profit £365,000 - overheads £254,000; source xero_pl_ytd_2026-04_2026-08.json, approved adjustment accrual-aug-payroll; metric operating_profit.ytd.actual | £10,000 = Operating profit, year to date, 1 April to 31 August 2026, difference against budget; actual minus budget; source approved adjustment accrual-aug-payroll, xero_pl_ytd_2026-04_2026-08.json, xero_budget.json; metric operating_profit.ytd.vs_budget | 9.9% = Operating profit, year to date, 1 April to 31 August 2026, % change against budget; (actual - budget) / budget; source approved adjustment accrual-aug-payroll, xero_pl_ytd_2026-04_2026-08.json, xero_budget.json; metric operating_profit.ytd.vs_budget_pct | £34,125 = Operating profit, year to date, 1 April to 31 August 2026, difference against prior year; actual minus prior year; source approved adjustment accrual-aug-payroll, xero_pl_ytd_2026-04_2026-08.json, xero_pl_ytd_2025-04_2025-08.json; metric operating_profit.ytd.vs_py | 44.4% = Operating profit, year to date, 1 April to 31 August 2026, % change against prior year; (actual - prior year) / prior year; source approved adjustment accrual-aug-payroll, xero_pl_ytd_2026-04_2026-08.json, xero_pl_ytd_2025-04_2025-08.json; metric operating_profit.ytd.vs_py_pct
+[4] 31.0% = Orchard Lane Foods: share of agency revenue, August 2026; client revenue / agency revenue; source xero_pl_by_client_2026-08.json, xero_pl_2026-08.json; metric client.orchard-lane.share.month.actual | £62,000 = Orchard Lane Foods: revenue, August 2026; Income, Client column; source xero_pl_by_client_2026-08.json; metric client.orchard-lane.revenue.month.actual | £4,333 = Orchard Lane Foods: revenue, August 2026 against its May to July average, difference; August minus three-month average; source xero_pl_by_client_2026-08.json; metric client.orchard-lane.revenue.month.vs_avg3m | 7.5% = Orchard Lane Foods: revenue, August 2026 against its May to July average, % change; (August - average) / average; source xero_pl_by_client_2026-08.json; metric client.orchard-lane.revenue.month.vs_avg3m_pct
+[5] £18,000 = Marlow &amp; Finch: revenue, August 2026; Income, Client column; source xero_pl_by_client_2026-08.json; metric client.marlow-finch.revenue.month.actual | £12,000 = Marlow &amp; Finch: revenue, August 2026 against its May to July average, difference; August minus three-month average; source xero_pl_by_client_2026-08.json; metric client.marlow-finch.revenue.month.vs_avg3m | 40.0% = Marlow &amp; Finch: revenue, August 2026 against its May to July average, % change; (August - average) / average; source xero_pl_by_client_2026-08.json; metric client.marlow-finch.revenue.month.vs_avg3m_pct | 14.4% = Marlow &amp; Finch: share of agency revenue, year to date; client revenue / agency revenue; source xero_pl_by_client_ytd_2026.json, xero_pl_ytd_2026-04_2026-08.json; metric client.marlow-finch.share.ytd.actual</a:t>
             </a:r>
             <a:endParaRPr lang="en-US" dirty="0"/>
           </a:p>
@@ -910,8 +883,8 @@
         </p:nvSpPr>
         <p:spPr>
           <a:xfrm>
-            <a:off x="548640" y="411480"/>
-            <a:ext cx="7315200" cy="365760"/>
+            <a:off x="548640" y="320040"/>
+            <a:ext cx="7315200" cy="320040"/>
           </a:xfrm>
           <a:prstGeom prst="rect">
             <a:avLst/>
@@ -949,8 +922,8 @@
         </p:nvSpPr>
         <p:spPr>
           <a:xfrm>
-            <a:off x="548640" y="731520"/>
-            <a:ext cx="7315200" cy="548640"/>
+            <a:off x="548640" y="621792"/>
+            <a:ext cx="10972800" cy="502920"/>
           </a:xfrm>
           <a:prstGeom prst="rect">
             <a:avLst/>
@@ -966,7 +939,7 @@
               <a:buNone/>
             </a:pPr>
             <a:r>
-              <a:rPr lang="en-US" sz="2600" dirty="0">
+              <a:rPr lang="en-US" sz="2400" dirty="0">
                 <a:solidFill>
                   <a:srgbClr val="1E2A3A"/>
                 </a:solidFill>
@@ -976,7 +949,7 @@
               </a:rPr>
               <a:t>Management commentary, August 2026</a:t>
             </a:r>
-            <a:endParaRPr lang="en-US" sz="2600" dirty="0"/>
+            <a:endParaRPr lang="en-US" sz="2400" dirty="0"/>
           </a:p>
         </p:txBody>
       </p:sp>
@@ -988,8 +961,8 @@
         </p:nvSpPr>
         <p:spPr>
           <a:xfrm>
-            <a:off x="548640" y="1463040"/>
-            <a:ext cx="6675120" cy="4480560"/>
+            <a:off x="548640" y="1234440"/>
+            <a:ext cx="11064240" cy="2651760"/>
           </a:xfrm>
           <a:prstGeom prst="rect">
             <a:avLst/>
@@ -1003,71 +976,211 @@
           <a:p>
             <a:pPr indent="0" marL="0">
               <a:lnSpc>
-                <a:spcPct val="115000"/>
+                <a:spcPct val="112000"/>
               </a:lnSpc>
               <a:spcAft>
-                <a:spcPts val="600"/>
+                <a:spcPts val="800"/>
               </a:spcAft>
               <a:buNone/>
             </a:pPr>
             <a:r>
-              <a:rPr lang="en-US" sz="1300" dirty="0">
+              <a:rPr lang="en-US" sz="1200" dirty="0">
                 <a:solidFill>
                   <a:srgbClr val="1E2A3A"/>
                 </a:solidFill>
-                <a:latin typeface="Georgia" pitchFamily="34" charset="0"/>
-                <a:ea typeface="Georgia" pitchFamily="34" charset="-122"/>
-                <a:cs typeface="Georgia" pitchFamily="34" charset="-120"/>
+                <a:latin typeface="Arial" pitchFamily="34" charset="0"/>
+                <a:ea typeface="Arial" pitchFamily="34" charset="-122"/>
+                <a:cs typeface="Arial" pitchFamily="34" charset="-120"/>
               </a:rPr>
-              <a:t>Revenue for August came in at £200,000, above budget by £10,000 (5.3%) and up on last year by £30,000 (17.6%), while gross profit of £68,000 was below budget by £4,200 (5.8%) as gross margin slipped to 34.0%, down 4.0 percentage points against budget. Operating profit for August was £17,500, below budget by £2,700 (13.4%) and slightly down on last year by £250 (1.4%).</a:t>
+              <a:t>Revenue for August came in at £200,000, above budget by £10,000 (5.3%) and up on last year by £30,000 (17.6%), while gross profit of £68,000 was below budget by £4,200 (5.8%) as gross margin slipped to 34.0%, down 4.0 percentage points against budget.</a:t>
             </a:r>
-            <a:endParaRPr lang="en-US" sz="1300" dirty="0"/>
+            <a:pPr indent="0" marL="0">
+              <a:lnSpc>
+                <a:spcPct val="112000"/>
+              </a:lnSpc>
+              <a:spcAft>
+                <a:spcPts val="800"/>
+              </a:spcAft>
+              <a:buNone/>
+            </a:pPr>
+            <a:r>
+              <a:rPr lang="en-US" sz="1200" baseline="30000" dirty="0">
+                <a:solidFill>
+                  <a:srgbClr val="6B7280"/>
+                </a:solidFill>
+                <a:latin typeface="Arial" pitchFamily="34" charset="0"/>
+                <a:ea typeface="Arial" pitchFamily="34" charset="-122"/>
+                <a:cs typeface="Arial" pitchFamily="34" charset="-120"/>
+              </a:rPr>
+              <a:t>[1]</a:t>
+            </a:r>
+            <a:pPr indent="0" marL="0">
+              <a:lnSpc>
+                <a:spcPct val="112000"/>
+              </a:lnSpc>
+              <a:spcAft>
+                <a:spcPts val="800"/>
+              </a:spcAft>
+              <a:buNone/>
+            </a:pPr>
+            <a:r>
+              <a:rPr lang="en-US" sz="1200" dirty="0">
+                <a:solidFill>
+                  <a:srgbClr val="1E2A3A"/>
+                </a:solidFill>
+                <a:latin typeface="Arial" pitchFamily="34" charset="0"/>
+                <a:ea typeface="Arial" pitchFamily="34" charset="-122"/>
+                <a:cs typeface="Arial" pitchFamily="34" charset="-120"/>
+              </a:rPr>
+              <a:t> Operating profit for August was £17,500, below budget by £2,700 (13.4%) and slightly down on last year by £250 (1.4%).</a:t>
+            </a:r>
+            <a:pPr indent="0" marL="0">
+              <a:lnSpc>
+                <a:spcPct val="112000"/>
+              </a:lnSpc>
+              <a:spcAft>
+                <a:spcPts val="800"/>
+              </a:spcAft>
+              <a:buNone/>
+            </a:pPr>
+            <a:r>
+              <a:rPr lang="en-US" sz="1200" baseline="30000" dirty="0">
+                <a:solidFill>
+                  <a:srgbClr val="6B7280"/>
+                </a:solidFill>
+                <a:latin typeface="Arial" pitchFamily="34" charset="0"/>
+                <a:ea typeface="Arial" pitchFamily="34" charset="-122"/>
+                <a:cs typeface="Arial" pitchFamily="34" charset="-120"/>
+              </a:rPr>
+              <a:t>[2]</a:t>
+            </a:r>
+            <a:endParaRPr lang="en-US" sz="1200" dirty="0"/>
           </a:p>
           <a:p>
             <a:pPr indent="0" marL="0">
               <a:lnSpc>
-                <a:spcPct val="115000"/>
+                <a:spcPct val="112000"/>
               </a:lnSpc>
               <a:spcAft>
-                <a:spcPts val="600"/>
+                <a:spcPts val="800"/>
               </a:spcAft>
               <a:buNone/>
             </a:pPr>
             <a:r>
-              <a:rPr lang="en-US" sz="1300" dirty="0">
+              <a:rPr lang="en-US" sz="1200" dirty="0">
                 <a:solidFill>
                   <a:srgbClr val="1E2A3A"/>
                 </a:solidFill>
-                <a:latin typeface="Georgia" pitchFamily="34" charset="0"/>
-                <a:ea typeface="Georgia" pitchFamily="34" charset="-122"/>
-                <a:cs typeface="Georgia" pitchFamily="34" charset="-120"/>
+                <a:latin typeface="Arial" pitchFamily="34" charset="0"/>
+                <a:ea typeface="Arial" pitchFamily="34" charset="-122"/>
+                <a:cs typeface="Arial" pitchFamily="34" charset="-120"/>
               </a:rPr>
               <a:t>Year to date the picture is stronger, with revenue of £960,000 above budget by £10,000 (1.1%) and up on last year by £115,000 (13.6%), and operating profit of £111,000 above budget by £10,000 (9.9%) and up on last year by £34,125 (44.4%).</a:t>
             </a:r>
-            <a:endParaRPr lang="en-US" sz="1300" dirty="0"/>
+            <a:pPr indent="0" marL="0">
+              <a:lnSpc>
+                <a:spcPct val="112000"/>
+              </a:lnSpc>
+              <a:spcAft>
+                <a:spcPts val="800"/>
+              </a:spcAft>
+              <a:buNone/>
+            </a:pPr>
+            <a:r>
+              <a:rPr lang="en-US" sz="1200" baseline="30000" dirty="0">
+                <a:solidFill>
+                  <a:srgbClr val="6B7280"/>
+                </a:solidFill>
+                <a:latin typeface="Arial" pitchFamily="34" charset="0"/>
+                <a:ea typeface="Arial" pitchFamily="34" charset="-122"/>
+                <a:cs typeface="Arial" pitchFamily="34" charset="-120"/>
+              </a:rPr>
+              <a:t>[3]</a:t>
+            </a:r>
+            <a:endParaRPr lang="en-US" sz="1200" dirty="0"/>
           </a:p>
           <a:p>
             <a:pPr indent="0" marL="0">
               <a:lnSpc>
-                <a:spcPct val="115000"/>
+                <a:spcPct val="112000"/>
               </a:lnSpc>
               <a:spcAft>
-                <a:spcPts val="600"/>
+                <a:spcPts val="800"/>
               </a:spcAft>
               <a:buNone/>
             </a:pPr>
             <a:r>
-              <a:rPr lang="en-US" sz="1300" dirty="0">
+              <a:rPr lang="en-US" sz="1200" dirty="0">
                 <a:solidFill>
                   <a:srgbClr val="1E2A3A"/>
                 </a:solidFill>
-                <a:latin typeface="Georgia" pitchFamily="34" charset="0"/>
-                <a:ea typeface="Georgia" pitchFamily="34" charset="-122"/>
-                <a:cs typeface="Georgia" pitchFamily="34" charset="-120"/>
+                <a:latin typeface="Arial" pitchFamily="34" charset="0"/>
+                <a:ea typeface="Arial" pitchFamily="34" charset="-122"/>
+                <a:cs typeface="Arial" pitchFamily="34" charset="-120"/>
               </a:rPr>
-              <a:t>On clients, Orchard Lane Foods remained the largest account at 31.0% of August revenue, with its month's revenue of £62,000 above its May to July average by £4,333 (7.5%). Marlow &amp; Finch's August revenue of £18,000 was notably below its May to July average by £12,000 (40.0%), and its share of year-to-date revenue at 14.4% is worth watching alongside the other client movements this month.</a:t>
+              <a:t>On clients, Orchard Lane Foods remained the largest account at 31.0% of August revenue, with its month's revenue of £62,000 above its May to July average by £4,333 (7.5%).</a:t>
             </a:r>
-            <a:endParaRPr lang="en-US" sz="1300" dirty="0"/>
+            <a:pPr indent="0" marL="0">
+              <a:lnSpc>
+                <a:spcPct val="112000"/>
+              </a:lnSpc>
+              <a:spcAft>
+                <a:spcPts val="800"/>
+              </a:spcAft>
+              <a:buNone/>
+            </a:pPr>
+            <a:r>
+              <a:rPr lang="en-US" sz="1200" baseline="30000" dirty="0">
+                <a:solidFill>
+                  <a:srgbClr val="6B7280"/>
+                </a:solidFill>
+                <a:latin typeface="Arial" pitchFamily="34" charset="0"/>
+                <a:ea typeface="Arial" pitchFamily="34" charset="-122"/>
+                <a:cs typeface="Arial" pitchFamily="34" charset="-120"/>
+              </a:rPr>
+              <a:t>[4]</a:t>
+            </a:r>
+            <a:pPr indent="0" marL="0">
+              <a:lnSpc>
+                <a:spcPct val="112000"/>
+              </a:lnSpc>
+              <a:spcAft>
+                <a:spcPts val="800"/>
+              </a:spcAft>
+              <a:buNone/>
+            </a:pPr>
+            <a:r>
+              <a:rPr lang="en-US" sz="1200" dirty="0">
+                <a:solidFill>
+                  <a:srgbClr val="1E2A3A"/>
+                </a:solidFill>
+                <a:latin typeface="Arial" pitchFamily="34" charset="0"/>
+                <a:ea typeface="Arial" pitchFamily="34" charset="-122"/>
+                <a:cs typeface="Arial" pitchFamily="34" charset="-120"/>
+              </a:rPr>
+              <a:t> Marlow &amp; Finch's August revenue of £18,000 was notably below its May to July average by £12,000 (40.0%), and its share of year-to-date revenue at 14.4% is worth watching alongside the other client movements this month.</a:t>
+            </a:r>
+            <a:pPr indent="0" marL="0">
+              <a:lnSpc>
+                <a:spcPct val="112000"/>
+              </a:lnSpc>
+              <a:spcAft>
+                <a:spcPts val="800"/>
+              </a:spcAft>
+              <a:buNone/>
+            </a:pPr>
+            <a:r>
+              <a:rPr lang="en-US" sz="1200" baseline="30000" dirty="0">
+                <a:solidFill>
+                  <a:srgbClr val="6B7280"/>
+                </a:solidFill>
+                <a:latin typeface="Arial" pitchFamily="34" charset="0"/>
+                <a:ea typeface="Arial" pitchFamily="34" charset="-122"/>
+                <a:cs typeface="Arial" pitchFamily="34" charset="-120"/>
+              </a:rPr>
+              <a:t>[5]</a:t>
+            </a:r>
+            <a:endParaRPr lang="en-US" sz="1200" dirty="0"/>
           </a:p>
         </p:txBody>
       </p:sp>
@@ -1086,22 +1199,22 @@
           </p:nvPr>
         </p:nvGraphicFramePr>
         <p:xfrm>
-          <a:off x="7498080" y="1508760"/>
-          <a:ext cx="4206240" cy="914400"/>
+          <a:off x="548640" y="4069080"/>
+          <a:ext cx="11064240" cy="914400"/>
         </p:xfrm>
         <a:graphic>
           <a:graphicData uri="http://schemas.openxmlformats.org/drawingml/2006/table">
             <a:tbl>
               <a:tblPr/>
               <a:tblGrid>
-                <a:gridCol w="1097280"/>
-                <a:gridCol w="658368"/>
-                <a:gridCol w="621792"/>
-                <a:gridCol w="621792"/>
-                <a:gridCol w="658368"/>
-                <a:gridCol w="548640"/>
+                <a:gridCol w="2148840"/>
+                <a:gridCol w="1691640"/>
+                <a:gridCol w="1691640"/>
+                <a:gridCol w="1691640"/>
+                <a:gridCol w="1920240"/>
+                <a:gridCol w="1920240"/>
               </a:tblGrid>
-              <a:tr h="310896">
+              <a:tr h="274320">
                 <a:tc>
                   <a:txBody>
                     <a:bodyPr/>
@@ -1117,7 +1230,7 @@
                       </a:endParaRPr>
                     </a:p>
                   </a:txBody>
-                  <a:tcPr marL="91440" marR="91440" marT="45720" marB="45720">
+                  <a:tcPr marL="73152" marR="73152" marT="27432" marB="27432">
                     <a:lnL w="6350" cap="flat" cmpd="sng" algn="ctr">
                       <a:solidFill>
                         <a:srgbClr val="D5D8D2"/>
@@ -1165,7 +1278,7 @@
                         <a:buNone/>
                       </a:pPr>
                       <a:r>
-                        <a:rPr lang="en-US" sz="900" b="1" dirty="0">
+                        <a:rPr lang="en-US" sz="1000" b="1" dirty="0">
                           <a:solidFill>
                             <a:srgbClr val="6B7280"/>
                           </a:solidFill>
@@ -1175,14 +1288,14 @@
                         </a:rPr>
                         <a:t>August</a:t>
                       </a:r>
-                      <a:endParaRPr lang="en-US" sz="900" dirty="0">
+                      <a:endParaRPr lang="en-US" sz="1000" dirty="0">
                         <a:latin typeface="Arial" charset="0"/>
                         <a:ea typeface="Arial" charset="0"/>
                         <a:cs typeface="Arial" charset="0"/>
                       </a:endParaRPr>
                     </a:p>
                   </a:txBody>
-                  <a:tcPr marL="91440" marR="91440" marT="45720" marB="45720">
+                  <a:tcPr marL="73152" marR="73152" marT="27432" marB="27432">
                     <a:lnL w="6350" cap="flat" cmpd="sng" algn="ctr">
                       <a:solidFill>
                         <a:srgbClr val="D5D8D2"/>
@@ -1230,7 +1343,7 @@
                         <a:buNone/>
                       </a:pPr>
                       <a:r>
-                        <a:rPr lang="en-US" sz="900" b="1" dirty="0">
+                        <a:rPr lang="en-US" sz="1000" b="1" dirty="0">
                           <a:solidFill>
                             <a:srgbClr val="6B7280"/>
                           </a:solidFill>
@@ -1240,14 +1353,14 @@
                         </a:rPr>
                         <a:t>Budget</a:t>
                       </a:r>
-                      <a:endParaRPr lang="en-US" sz="900" dirty="0">
+                      <a:endParaRPr lang="en-US" sz="1000" dirty="0">
                         <a:latin typeface="Arial" charset="0"/>
                         <a:ea typeface="Arial" charset="0"/>
                         <a:cs typeface="Arial" charset="0"/>
                       </a:endParaRPr>
                     </a:p>
                   </a:txBody>
-                  <a:tcPr marL="91440" marR="91440" marT="45720" marB="45720">
+                  <a:tcPr marL="73152" marR="73152" marT="27432" marB="27432">
                     <a:lnL w="6350" cap="flat" cmpd="sng" algn="ctr">
                       <a:solidFill>
                         <a:srgbClr val="D5D8D2"/>
@@ -1295,7 +1408,7 @@
                         <a:buNone/>
                       </a:pPr>
                       <a:r>
-                        <a:rPr lang="en-US" sz="900" b="1" dirty="0">
+                        <a:rPr lang="en-US" sz="1000" b="1" dirty="0">
                           <a:solidFill>
                             <a:srgbClr val="6B7280"/>
                           </a:solidFill>
@@ -1305,14 +1418,14 @@
                         </a:rPr>
                         <a:t>Last year</a:t>
                       </a:r>
-                      <a:endParaRPr lang="en-US" sz="900" dirty="0">
+                      <a:endParaRPr lang="en-US" sz="1000" dirty="0">
                         <a:latin typeface="Arial" charset="0"/>
                         <a:ea typeface="Arial" charset="0"/>
                         <a:cs typeface="Arial" charset="0"/>
                       </a:endParaRPr>
                     </a:p>
                   </a:txBody>
-                  <a:tcPr marL="91440" marR="91440" marT="45720" marB="45720">
+                  <a:tcPr marL="73152" marR="73152" marT="27432" marB="27432">
                     <a:lnL w="6350" cap="flat" cmpd="sng" algn="ctr">
                       <a:solidFill>
                         <a:srgbClr val="D5D8D2"/>
@@ -1360,7 +1473,7 @@
                         <a:buNone/>
                       </a:pPr>
                       <a:r>
-                        <a:rPr lang="en-US" sz="900" b="1" dirty="0">
+                        <a:rPr lang="en-US" sz="1000" b="1" dirty="0">
                           <a:solidFill>
                             <a:srgbClr val="6B7280"/>
                           </a:solidFill>
@@ -1370,14 +1483,14 @@
                         </a:rPr>
                         <a:t>Year to date</a:t>
                       </a:r>
-                      <a:endParaRPr lang="en-US" sz="900" dirty="0">
+                      <a:endParaRPr lang="en-US" sz="1000" dirty="0">
                         <a:latin typeface="Arial" charset="0"/>
                         <a:ea typeface="Arial" charset="0"/>
                         <a:cs typeface="Arial" charset="0"/>
                       </a:endParaRPr>
                     </a:p>
                   </a:txBody>
-                  <a:tcPr marL="91440" marR="91440" marT="45720" marB="45720">
+                  <a:tcPr marL="73152" marR="73152" marT="27432" marB="27432">
                     <a:lnL w="6350" cap="flat" cmpd="sng" algn="ctr">
                       <a:solidFill>
                         <a:srgbClr val="D5D8D2"/>
@@ -1425,7 +1538,7 @@
                         <a:buNone/>
                       </a:pPr>
                       <a:r>
-                        <a:rPr lang="en-US" sz="900" b="1" dirty="0">
+                        <a:rPr lang="en-US" sz="1000" b="1" dirty="0">
                           <a:solidFill>
                             <a:srgbClr val="6B7280"/>
                           </a:solidFill>
@@ -1433,16 +1546,16 @@
                           <a:ea typeface="Arial" pitchFamily="34" charset="-122"/>
                           <a:cs typeface="Arial" pitchFamily="34" charset="-120"/>
                         </a:rPr>
-                        <a:t>Budget</a:t>
+                        <a:t>Budget, year to date</a:t>
                       </a:r>
-                      <a:endParaRPr lang="en-US" sz="900" dirty="0">
+                      <a:endParaRPr lang="en-US" sz="1000" dirty="0">
                         <a:latin typeface="Arial" charset="0"/>
                         <a:ea typeface="Arial" charset="0"/>
                         <a:cs typeface="Arial" charset="0"/>
                       </a:endParaRPr>
                     </a:p>
                   </a:txBody>
-                  <a:tcPr marL="91440" marR="91440" marT="45720" marB="45720">
+                  <a:tcPr marL="73152" marR="73152" marT="27432" marB="27432">
                     <a:lnL w="6350" cap="flat" cmpd="sng" algn="ctr">
                       <a:solidFill>
                         <a:srgbClr val="D5D8D2"/>
@@ -1482,7 +1595,7 @@
                   </a:tcPr>
                 </a:tc>
               </a:tr>
-              <a:tr h="310896">
+              <a:tr h="274320">
                 <a:tc>
                   <a:txBody>
                     <a:bodyPr/>
@@ -1492,7 +1605,7 @@
                         <a:buNone/>
                       </a:pPr>
                       <a:r>
-                        <a:rPr lang="en-US" sz="1000" dirty="0">
+                        <a:rPr lang="en-US" sz="1100" dirty="0">
                           <a:solidFill>
                             <a:srgbClr val="1E2A3A"/>
                           </a:solidFill>
@@ -1502,14 +1615,14 @@
                         </a:rPr>
                         <a:t>Revenue</a:t>
                       </a:r>
-                      <a:endParaRPr lang="en-US" sz="1000" dirty="0">
+                      <a:endParaRPr lang="en-US" sz="1100" dirty="0">
                         <a:latin typeface="Arial" charset="0"/>
                         <a:ea typeface="Arial" charset="0"/>
                         <a:cs typeface="Arial" charset="0"/>
                       </a:endParaRPr>
                     </a:p>
                   </a:txBody>
-                  <a:tcPr marL="91440" marR="91440" marT="45720" marB="45720">
+                  <a:tcPr marL="73152" marR="73152" marT="27432" marB="27432">
                     <a:lnL w="6350" cap="flat" cmpd="sng" algn="ctr">
                       <a:solidFill>
                         <a:srgbClr val="D5D8D2"/>
@@ -1557,7 +1670,7 @@
                         <a:buNone/>
                       </a:pPr>
                       <a:r>
-                        <a:rPr lang="en-US" sz="1000" dirty="0">
+                        <a:rPr lang="en-US" sz="1100" dirty="0">
                           <a:solidFill>
                             <a:srgbClr val="1E2A3A"/>
                           </a:solidFill>
@@ -1567,14 +1680,14 @@
                         </a:rPr>
                         <a:t>£200,000</a:t>
                       </a:r>
-                      <a:endParaRPr lang="en-US" sz="1000" dirty="0">
+                      <a:endParaRPr lang="en-US" sz="1100" dirty="0">
                         <a:latin typeface="Arial" charset="0"/>
                         <a:ea typeface="Arial" charset="0"/>
                         <a:cs typeface="Arial" charset="0"/>
                       </a:endParaRPr>
                     </a:p>
                   </a:txBody>
-                  <a:tcPr marL="91440" marR="91440" marT="45720" marB="45720">
+                  <a:tcPr marL="73152" marR="73152" marT="27432" marB="27432">
                     <a:lnL w="6350" cap="flat" cmpd="sng" algn="ctr">
                       <a:solidFill>
                         <a:srgbClr val="D5D8D2"/>
@@ -1622,7 +1735,7 @@
                         <a:buNone/>
                       </a:pPr>
                       <a:r>
-                        <a:rPr lang="en-US" sz="1000" dirty="0">
+                        <a:rPr lang="en-US" sz="1100" dirty="0">
                           <a:solidFill>
                             <a:srgbClr val="1E2A3A"/>
                           </a:solidFill>
@@ -1632,14 +1745,14 @@
                         </a:rPr>
                         <a:t>£190,000</a:t>
                       </a:r>
-                      <a:endParaRPr lang="en-US" sz="1000" dirty="0">
+                      <a:endParaRPr lang="en-US" sz="1100" dirty="0">
                         <a:latin typeface="Arial" charset="0"/>
                         <a:ea typeface="Arial" charset="0"/>
                         <a:cs typeface="Arial" charset="0"/>
                       </a:endParaRPr>
                     </a:p>
                   </a:txBody>
-                  <a:tcPr marL="91440" marR="91440" marT="45720" marB="45720">
+                  <a:tcPr marL="73152" marR="73152" marT="27432" marB="27432">
                     <a:lnL w="6350" cap="flat" cmpd="sng" algn="ctr">
                       <a:solidFill>
                         <a:srgbClr val="D5D8D2"/>
@@ -1687,7 +1800,7 @@
                         <a:buNone/>
                       </a:pPr>
                       <a:r>
-                        <a:rPr lang="en-US" sz="1000" dirty="0">
+                        <a:rPr lang="en-US" sz="1100" dirty="0">
                           <a:solidFill>
                             <a:srgbClr val="1E2A3A"/>
                           </a:solidFill>
@@ -1697,14 +1810,14 @@
                         </a:rPr>
                         <a:t>£170,000</a:t>
                       </a:r>
-                      <a:endParaRPr lang="en-US" sz="1000" dirty="0">
+                      <a:endParaRPr lang="en-US" sz="1100" dirty="0">
                         <a:latin typeface="Arial" charset="0"/>
                         <a:ea typeface="Arial" charset="0"/>
                         <a:cs typeface="Arial" charset="0"/>
                       </a:endParaRPr>
                     </a:p>
                   </a:txBody>
-                  <a:tcPr marL="91440" marR="91440" marT="45720" marB="45720">
+                  <a:tcPr marL="73152" marR="73152" marT="27432" marB="27432">
                     <a:lnL w="6350" cap="flat" cmpd="sng" algn="ctr">
                       <a:solidFill>
                         <a:srgbClr val="D5D8D2"/>
@@ -1752,7 +1865,7 @@
                         <a:buNone/>
                       </a:pPr>
                       <a:r>
-                        <a:rPr lang="en-US" sz="1000" dirty="0">
+                        <a:rPr lang="en-US" sz="1100" dirty="0">
                           <a:solidFill>
                             <a:srgbClr val="1E2A3A"/>
                           </a:solidFill>
@@ -1762,14 +1875,14 @@
                         </a:rPr>
                         <a:t>£960,000</a:t>
                       </a:r>
-                      <a:endParaRPr lang="en-US" sz="1000" dirty="0">
+                      <a:endParaRPr lang="en-US" sz="1100" dirty="0">
                         <a:latin typeface="Arial" charset="0"/>
                         <a:ea typeface="Arial" charset="0"/>
                         <a:cs typeface="Arial" charset="0"/>
                       </a:endParaRPr>
                     </a:p>
                   </a:txBody>
-                  <a:tcPr marL="91440" marR="91440" marT="45720" marB="45720">
+                  <a:tcPr marL="73152" marR="73152" marT="27432" marB="27432">
                     <a:lnL w="6350" cap="flat" cmpd="sng" algn="ctr">
                       <a:solidFill>
                         <a:srgbClr val="D5D8D2"/>
@@ -1817,7 +1930,7 @@
                         <a:buNone/>
                       </a:pPr>
                       <a:r>
-                        <a:rPr lang="en-US" sz="1000" dirty="0">
+                        <a:rPr lang="en-US" sz="1100" dirty="0">
                           <a:solidFill>
                             <a:srgbClr val="1E2A3A"/>
                           </a:solidFill>
@@ -1827,14 +1940,14 @@
                         </a:rPr>
                         <a:t>£950,000</a:t>
                       </a:r>
-                      <a:endParaRPr lang="en-US" sz="1000" dirty="0">
+                      <a:endParaRPr lang="en-US" sz="1100" dirty="0">
                         <a:latin typeface="Arial" charset="0"/>
                         <a:ea typeface="Arial" charset="0"/>
                         <a:cs typeface="Arial" charset="0"/>
                       </a:endParaRPr>
                     </a:p>
                   </a:txBody>
-                  <a:tcPr marL="91440" marR="91440" marT="45720" marB="45720">
+                  <a:tcPr marL="73152" marR="73152" marT="27432" marB="27432">
                     <a:lnL w="6350" cap="flat" cmpd="sng" algn="ctr">
                       <a:solidFill>
                         <a:srgbClr val="D5D8D2"/>
@@ -1874,7 +1987,7 @@
                   </a:tcPr>
                 </a:tc>
               </a:tr>
-              <a:tr h="310896">
+              <a:tr h="274320">
                 <a:tc>
                   <a:txBody>
                     <a:bodyPr/>
@@ -1884,7 +1997,7 @@
                         <a:buNone/>
                       </a:pPr>
                       <a:r>
-                        <a:rPr lang="en-US" sz="1000" dirty="0">
+                        <a:rPr lang="en-US" sz="1100" dirty="0">
                           <a:solidFill>
                             <a:srgbClr val="1E2A3A"/>
                           </a:solidFill>
@@ -1894,14 +2007,14 @@
                         </a:rPr>
                         <a:t>Gross profit</a:t>
                       </a:r>
-                      <a:endParaRPr lang="en-US" sz="1000" dirty="0">
+                      <a:endParaRPr lang="en-US" sz="1100" dirty="0">
                         <a:latin typeface="Arial" charset="0"/>
                         <a:ea typeface="Arial" charset="0"/>
                         <a:cs typeface="Arial" charset="0"/>
                       </a:endParaRPr>
                     </a:p>
                   </a:txBody>
-                  <a:tcPr marL="91440" marR="91440" marT="45720" marB="45720">
+                  <a:tcPr marL="73152" marR="73152" marT="27432" marB="27432">
                     <a:lnL w="6350" cap="flat" cmpd="sng" algn="ctr">
                       <a:solidFill>
                         <a:srgbClr val="D5D8D2"/>
@@ -1949,7 +2062,7 @@
                         <a:buNone/>
                       </a:pPr>
                       <a:r>
-                        <a:rPr lang="en-US" sz="1000" dirty="0">
+                        <a:rPr lang="en-US" sz="1100" dirty="0">
                           <a:solidFill>
                             <a:srgbClr val="1E2A3A"/>
                           </a:solidFill>
@@ -1959,14 +2072,14 @@
                         </a:rPr>
                         <a:t>£68,000</a:t>
                       </a:r>
-                      <a:endParaRPr lang="en-US" sz="1000" dirty="0">
+                      <a:endParaRPr lang="en-US" sz="1100" dirty="0">
                         <a:latin typeface="Arial" charset="0"/>
                         <a:ea typeface="Arial" charset="0"/>
                         <a:cs typeface="Arial" charset="0"/>
                       </a:endParaRPr>
                     </a:p>
                   </a:txBody>
-                  <a:tcPr marL="91440" marR="91440" marT="45720" marB="45720">
+                  <a:tcPr marL="73152" marR="73152" marT="27432" marB="27432">
                     <a:lnL w="6350" cap="flat" cmpd="sng" algn="ctr">
                       <a:solidFill>
                         <a:srgbClr val="D5D8D2"/>
@@ -2014,7 +2127,7 @@
                         <a:buNone/>
                       </a:pPr>
                       <a:r>
-                        <a:rPr lang="en-US" sz="1000" dirty="0">
+                        <a:rPr lang="en-US" sz="1100" dirty="0">
                           <a:solidFill>
                             <a:srgbClr val="1E2A3A"/>
                           </a:solidFill>
@@ -2024,14 +2137,14 @@
                         </a:rPr>
                         <a:t>£72,200</a:t>
                       </a:r>
-                      <a:endParaRPr lang="en-US" sz="1000" dirty="0">
+                      <a:endParaRPr lang="en-US" sz="1100" dirty="0">
                         <a:latin typeface="Arial" charset="0"/>
                         <a:ea typeface="Arial" charset="0"/>
                         <a:cs typeface="Arial" charset="0"/>
                       </a:endParaRPr>
                     </a:p>
                   </a:txBody>
-                  <a:tcPr marL="91440" marR="91440" marT="45720" marB="45720">
+                  <a:tcPr marL="73152" marR="73152" marT="27432" marB="27432">
                     <a:lnL w="6350" cap="flat" cmpd="sng" algn="ctr">
                       <a:solidFill>
                         <a:srgbClr val="D5D8D2"/>
@@ -2079,7 +2192,7 @@
                         <a:buNone/>
                       </a:pPr>
                       <a:r>
-                        <a:rPr lang="en-US" sz="1000" dirty="0">
+                        <a:rPr lang="en-US" sz="1100" dirty="0">
                           <a:solidFill>
                             <a:srgbClr val="1E2A3A"/>
                           </a:solidFill>
@@ -2089,14 +2202,14 @@
                         </a:rPr>
                         <a:t>£63,750</a:t>
                       </a:r>
-                      <a:endParaRPr lang="en-US" sz="1000" dirty="0">
+                      <a:endParaRPr lang="en-US" sz="1100" dirty="0">
                         <a:latin typeface="Arial" charset="0"/>
                         <a:ea typeface="Arial" charset="0"/>
                         <a:cs typeface="Arial" charset="0"/>
                       </a:endParaRPr>
                     </a:p>
                   </a:txBody>
-                  <a:tcPr marL="91440" marR="91440" marT="45720" marB="45720">
+                  <a:tcPr marL="73152" marR="73152" marT="27432" marB="27432">
                     <a:lnL w="6350" cap="flat" cmpd="sng" algn="ctr">
                       <a:solidFill>
                         <a:srgbClr val="D5D8D2"/>
@@ -2144,7 +2257,7 @@
                         <a:buNone/>
                       </a:pPr>
                       <a:r>
-                        <a:rPr lang="en-US" sz="1000" dirty="0">
+                        <a:rPr lang="en-US" sz="1100" dirty="0">
                           <a:solidFill>
                             <a:srgbClr val="1E2A3A"/>
                           </a:solidFill>
@@ -2154,14 +2267,14 @@
                         </a:rPr>
                         <a:t>£365,000</a:t>
                       </a:r>
-                      <a:endParaRPr lang="en-US" sz="1000" dirty="0">
+                      <a:endParaRPr lang="en-US" sz="1100" dirty="0">
                         <a:latin typeface="Arial" charset="0"/>
                         <a:ea typeface="Arial" charset="0"/>
                         <a:cs typeface="Arial" charset="0"/>
                       </a:endParaRPr>
                     </a:p>
                   </a:txBody>
-                  <a:tcPr marL="91440" marR="91440" marT="45720" marB="45720">
+                  <a:tcPr marL="73152" marR="73152" marT="27432" marB="27432">
                     <a:lnL w="6350" cap="flat" cmpd="sng" algn="ctr">
                       <a:solidFill>
                         <a:srgbClr val="D5D8D2"/>
@@ -2209,7 +2322,7 @@
                         <a:buNone/>
                       </a:pPr>
                       <a:r>
-                        <a:rPr lang="en-US" sz="1000" dirty="0">
+                        <a:rPr lang="en-US" sz="1100" dirty="0">
                           <a:solidFill>
                             <a:srgbClr val="1E2A3A"/>
                           </a:solidFill>
@@ -2219,14 +2332,14 @@
                         </a:rPr>
                         <a:t>£361,000</a:t>
                       </a:r>
-                      <a:endParaRPr lang="en-US" sz="1000" dirty="0">
+                      <a:endParaRPr lang="en-US" sz="1100" dirty="0">
                         <a:latin typeface="Arial" charset="0"/>
                         <a:ea typeface="Arial" charset="0"/>
                         <a:cs typeface="Arial" charset="0"/>
                       </a:endParaRPr>
                     </a:p>
                   </a:txBody>
-                  <a:tcPr marL="91440" marR="91440" marT="45720" marB="45720">
+                  <a:tcPr marL="73152" marR="73152" marT="27432" marB="27432">
                     <a:lnL w="6350" cap="flat" cmpd="sng" algn="ctr">
                       <a:solidFill>
                         <a:srgbClr val="D5D8D2"/>
@@ -2266,7 +2379,7 @@
                   </a:tcPr>
                 </a:tc>
               </a:tr>
-              <a:tr h="310896">
+              <a:tr h="274320">
                 <a:tc>
                   <a:txBody>
                     <a:bodyPr/>
@@ -2276,7 +2389,7 @@
                         <a:buNone/>
                       </a:pPr>
                       <a:r>
-                        <a:rPr lang="en-US" sz="1000" dirty="0">
+                        <a:rPr lang="en-US" sz="1100" dirty="0">
                           <a:solidFill>
                             <a:srgbClr val="1E2A3A"/>
                           </a:solidFill>
@@ -2286,14 +2399,14 @@
                         </a:rPr>
                         <a:t>Gross margin</a:t>
                       </a:r>
-                      <a:endParaRPr lang="en-US" sz="1000" dirty="0">
+                      <a:endParaRPr lang="en-US" sz="1100" dirty="0">
                         <a:latin typeface="Arial" charset="0"/>
                         <a:ea typeface="Arial" charset="0"/>
                         <a:cs typeface="Arial" charset="0"/>
                       </a:endParaRPr>
                     </a:p>
                   </a:txBody>
-                  <a:tcPr marL="91440" marR="91440" marT="45720" marB="45720">
+                  <a:tcPr marL="73152" marR="73152" marT="27432" marB="27432">
                     <a:lnL w="6350" cap="flat" cmpd="sng" algn="ctr">
                       <a:solidFill>
                         <a:srgbClr val="D5D8D2"/>
@@ -2341,7 +2454,7 @@
                         <a:buNone/>
                       </a:pPr>
                       <a:r>
-                        <a:rPr lang="en-US" sz="1000" dirty="0">
+                        <a:rPr lang="en-US" sz="1100" dirty="0">
                           <a:solidFill>
                             <a:srgbClr val="1E2A3A"/>
                           </a:solidFill>
@@ -2351,14 +2464,14 @@
                         </a:rPr>
                         <a:t>34.0%</a:t>
                       </a:r>
-                      <a:endParaRPr lang="en-US" sz="1000" dirty="0">
+                      <a:endParaRPr lang="en-US" sz="1100" dirty="0">
                         <a:latin typeface="Arial" charset="0"/>
                         <a:ea typeface="Arial" charset="0"/>
                         <a:cs typeface="Arial" charset="0"/>
                       </a:endParaRPr>
                     </a:p>
                   </a:txBody>
-                  <a:tcPr marL="91440" marR="91440" marT="45720" marB="45720">
+                  <a:tcPr marL="73152" marR="73152" marT="27432" marB="27432">
                     <a:lnL w="6350" cap="flat" cmpd="sng" algn="ctr">
                       <a:solidFill>
                         <a:srgbClr val="D5D8D2"/>
@@ -2406,7 +2519,7 @@
                         <a:buNone/>
                       </a:pPr>
                       <a:r>
-                        <a:rPr lang="en-US" sz="1000" dirty="0">
+                        <a:rPr lang="en-US" sz="1100" dirty="0">
                           <a:solidFill>
                             <a:srgbClr val="1E2A3A"/>
                           </a:solidFill>
@@ -2416,14 +2529,14 @@
                         </a:rPr>
                         <a:t>38.0%</a:t>
                       </a:r>
-                      <a:endParaRPr lang="en-US" sz="1000" dirty="0">
+                      <a:endParaRPr lang="en-US" sz="1100" dirty="0">
                         <a:latin typeface="Arial" charset="0"/>
                         <a:ea typeface="Arial" charset="0"/>
                         <a:cs typeface="Arial" charset="0"/>
                       </a:endParaRPr>
                     </a:p>
                   </a:txBody>
-                  <a:tcPr marL="91440" marR="91440" marT="45720" marB="45720">
+                  <a:tcPr marL="73152" marR="73152" marT="27432" marB="27432">
                     <a:lnL w="6350" cap="flat" cmpd="sng" algn="ctr">
                       <a:solidFill>
                         <a:srgbClr val="D5D8D2"/>
@@ -2471,7 +2584,7 @@
                         <a:buNone/>
                       </a:pPr>
                       <a:r>
-                        <a:rPr lang="en-US" sz="1000" dirty="0">
+                        <a:rPr lang="en-US" sz="1100" dirty="0">
                           <a:solidFill>
                             <a:srgbClr val="1E2A3A"/>
                           </a:solidFill>
@@ -2481,14 +2594,14 @@
                         </a:rPr>
                         <a:t>37.5%</a:t>
                       </a:r>
-                      <a:endParaRPr lang="en-US" sz="1000" dirty="0">
+                      <a:endParaRPr lang="en-US" sz="1100" dirty="0">
                         <a:latin typeface="Arial" charset="0"/>
                         <a:ea typeface="Arial" charset="0"/>
                         <a:cs typeface="Arial" charset="0"/>
                       </a:endParaRPr>
                     </a:p>
                   </a:txBody>
-                  <a:tcPr marL="91440" marR="91440" marT="45720" marB="45720">
+                  <a:tcPr marL="73152" marR="73152" marT="27432" marB="27432">
                     <a:lnL w="6350" cap="flat" cmpd="sng" algn="ctr">
                       <a:solidFill>
                         <a:srgbClr val="D5D8D2"/>
@@ -2536,7 +2649,7 @@
                         <a:buNone/>
                       </a:pPr>
                       <a:r>
-                        <a:rPr lang="en-US" sz="1000" dirty="0">
+                        <a:rPr lang="en-US" sz="1100" dirty="0">
                           <a:solidFill>
                             <a:srgbClr val="1E2A3A"/>
                           </a:solidFill>
@@ -2546,14 +2659,14 @@
                         </a:rPr>
                         <a:t>38.0%</a:t>
                       </a:r>
-                      <a:endParaRPr lang="en-US" sz="1000" dirty="0">
+                      <a:endParaRPr lang="en-US" sz="1100" dirty="0">
                         <a:latin typeface="Arial" charset="0"/>
                         <a:ea typeface="Arial" charset="0"/>
                         <a:cs typeface="Arial" charset="0"/>
                       </a:endParaRPr>
                     </a:p>
                   </a:txBody>
-                  <a:tcPr marL="91440" marR="91440" marT="45720" marB="45720">
+                  <a:tcPr marL="73152" marR="73152" marT="27432" marB="27432">
                     <a:lnL w="6350" cap="flat" cmpd="sng" algn="ctr">
                       <a:solidFill>
                         <a:srgbClr val="D5D8D2"/>
@@ -2601,7 +2714,7 @@
                         <a:buNone/>
                       </a:pPr>
                       <a:r>
-                        <a:rPr lang="en-US" sz="1000" dirty="0">
+                        <a:rPr lang="en-US" sz="1100" dirty="0">
                           <a:solidFill>
                             <a:srgbClr val="1E2A3A"/>
                           </a:solidFill>
@@ -2611,14 +2724,14 @@
                         </a:rPr>
                         <a:t>38.0%</a:t>
                       </a:r>
-                      <a:endParaRPr lang="en-US" sz="1000" dirty="0">
+                      <a:endParaRPr lang="en-US" sz="1100" dirty="0">
                         <a:latin typeface="Arial" charset="0"/>
                         <a:ea typeface="Arial" charset="0"/>
                         <a:cs typeface="Arial" charset="0"/>
                       </a:endParaRPr>
                     </a:p>
                   </a:txBody>
-                  <a:tcPr marL="91440" marR="91440" marT="45720" marB="45720">
+                  <a:tcPr marL="73152" marR="73152" marT="27432" marB="27432">
                     <a:lnL w="6350" cap="flat" cmpd="sng" algn="ctr">
                       <a:solidFill>
                         <a:srgbClr val="D5D8D2"/>
@@ -2658,7 +2771,7 @@
                   </a:tcPr>
                 </a:tc>
               </a:tr>
-              <a:tr h="310896">
+              <a:tr h="274320">
                 <a:tc>
                   <a:txBody>
                     <a:bodyPr/>
@@ -2668,7 +2781,7 @@
                         <a:buNone/>
                       </a:pPr>
                       <a:r>
-                        <a:rPr lang="en-US" sz="1000" dirty="0">
+                        <a:rPr lang="en-US" sz="1100" dirty="0">
                           <a:solidFill>
                             <a:srgbClr val="1E2A3A"/>
                           </a:solidFill>
@@ -2678,14 +2791,14 @@
                         </a:rPr>
                         <a:t>Overheads</a:t>
                       </a:r>
-                      <a:endParaRPr lang="en-US" sz="1000" dirty="0">
+                      <a:endParaRPr lang="en-US" sz="1100" dirty="0">
                         <a:latin typeface="Arial" charset="0"/>
                         <a:ea typeface="Arial" charset="0"/>
                         <a:cs typeface="Arial" charset="0"/>
                       </a:endParaRPr>
                     </a:p>
                   </a:txBody>
-                  <a:tcPr marL="91440" marR="91440" marT="45720" marB="45720">
+                  <a:tcPr marL="73152" marR="73152" marT="27432" marB="27432">
                     <a:lnL w="6350" cap="flat" cmpd="sng" algn="ctr">
                       <a:solidFill>
                         <a:srgbClr val="D5D8D2"/>
@@ -2733,7 +2846,7 @@
                         <a:buNone/>
                       </a:pPr>
                       <a:r>
-                        <a:rPr lang="en-US" sz="1000" dirty="0">
+                        <a:rPr lang="en-US" sz="1100" dirty="0">
                           <a:solidFill>
                             <a:srgbClr val="1E2A3A"/>
                           </a:solidFill>
@@ -2743,14 +2856,14 @@
                         </a:rPr>
                         <a:t>£50,500</a:t>
                       </a:r>
-                      <a:endParaRPr lang="en-US" sz="1000" dirty="0">
+                      <a:endParaRPr lang="en-US" sz="1100" dirty="0">
                         <a:latin typeface="Arial" charset="0"/>
                         <a:ea typeface="Arial" charset="0"/>
                         <a:cs typeface="Arial" charset="0"/>
                       </a:endParaRPr>
                     </a:p>
                   </a:txBody>
-                  <a:tcPr marL="91440" marR="91440" marT="45720" marB="45720">
+                  <a:tcPr marL="73152" marR="73152" marT="27432" marB="27432">
                     <a:lnL w="6350" cap="flat" cmpd="sng" algn="ctr">
                       <a:solidFill>
                         <a:srgbClr val="D5D8D2"/>
@@ -2798,7 +2911,7 @@
                         <a:buNone/>
                       </a:pPr>
                       <a:r>
-                        <a:rPr lang="en-US" sz="1000" dirty="0">
+                        <a:rPr lang="en-US" sz="1100" dirty="0">
                           <a:solidFill>
                             <a:srgbClr val="1E2A3A"/>
                           </a:solidFill>
@@ -2808,14 +2921,14 @@
                         </a:rPr>
                         <a:t>£52,000</a:t>
                       </a:r>
-                      <a:endParaRPr lang="en-US" sz="1000" dirty="0">
+                      <a:endParaRPr lang="en-US" sz="1100" dirty="0">
                         <a:latin typeface="Arial" charset="0"/>
                         <a:ea typeface="Arial" charset="0"/>
                         <a:cs typeface="Arial" charset="0"/>
                       </a:endParaRPr>
                     </a:p>
                   </a:txBody>
-                  <a:tcPr marL="91440" marR="91440" marT="45720" marB="45720">
+                  <a:tcPr marL="73152" marR="73152" marT="27432" marB="27432">
                     <a:lnL w="6350" cap="flat" cmpd="sng" algn="ctr">
                       <a:solidFill>
                         <a:srgbClr val="D5D8D2"/>
@@ -2863,7 +2976,7 @@
                         <a:buNone/>
                       </a:pPr>
                       <a:r>
-                        <a:rPr lang="en-US" sz="1000" dirty="0">
+                        <a:rPr lang="en-US" sz="1100" dirty="0">
                           <a:solidFill>
                             <a:srgbClr val="1E2A3A"/>
                           </a:solidFill>
@@ -2873,14 +2986,14 @@
                         </a:rPr>
                         <a:t>£46,000</a:t>
                       </a:r>
-                      <a:endParaRPr lang="en-US" sz="1000" dirty="0">
+                      <a:endParaRPr lang="en-US" sz="1100" dirty="0">
                         <a:latin typeface="Arial" charset="0"/>
                         <a:ea typeface="Arial" charset="0"/>
                         <a:cs typeface="Arial" charset="0"/>
                       </a:endParaRPr>
                     </a:p>
                   </a:txBody>
-                  <a:tcPr marL="91440" marR="91440" marT="45720" marB="45720">
+                  <a:tcPr marL="73152" marR="73152" marT="27432" marB="27432">
                     <a:lnL w="6350" cap="flat" cmpd="sng" algn="ctr">
                       <a:solidFill>
                         <a:srgbClr val="D5D8D2"/>
@@ -2928,7 +3041,7 @@
                         <a:buNone/>
                       </a:pPr>
                       <a:r>
-                        <a:rPr lang="en-US" sz="1000" dirty="0">
+                        <a:rPr lang="en-US" sz="1100" dirty="0">
                           <a:solidFill>
                             <a:srgbClr val="1E2A3A"/>
                           </a:solidFill>
@@ -2938,14 +3051,14 @@
                         </a:rPr>
                         <a:t>£254,000</a:t>
                       </a:r>
-                      <a:endParaRPr lang="en-US" sz="1000" dirty="0">
+                      <a:endParaRPr lang="en-US" sz="1100" dirty="0">
                         <a:latin typeface="Arial" charset="0"/>
                         <a:ea typeface="Arial" charset="0"/>
                         <a:cs typeface="Arial" charset="0"/>
                       </a:endParaRPr>
                     </a:p>
                   </a:txBody>
-                  <a:tcPr marL="91440" marR="91440" marT="45720" marB="45720">
+                  <a:tcPr marL="73152" marR="73152" marT="27432" marB="27432">
                     <a:lnL w="6350" cap="flat" cmpd="sng" algn="ctr">
                       <a:solidFill>
                         <a:srgbClr val="D5D8D2"/>
@@ -2993,7 +3106,7 @@
                         <a:buNone/>
                       </a:pPr>
                       <a:r>
-                        <a:rPr lang="en-US" sz="1000" dirty="0">
+                        <a:rPr lang="en-US" sz="1100" dirty="0">
                           <a:solidFill>
                             <a:srgbClr val="1E2A3A"/>
                           </a:solidFill>
@@ -3003,14 +3116,14 @@
                         </a:rPr>
                         <a:t>£260,000</a:t>
                       </a:r>
-                      <a:endParaRPr lang="en-US" sz="1000" dirty="0">
+                      <a:endParaRPr lang="en-US" sz="1100" dirty="0">
                         <a:latin typeface="Arial" charset="0"/>
                         <a:ea typeface="Arial" charset="0"/>
                         <a:cs typeface="Arial" charset="0"/>
                       </a:endParaRPr>
                     </a:p>
                   </a:txBody>
-                  <a:tcPr marL="91440" marR="91440" marT="45720" marB="45720">
+                  <a:tcPr marL="73152" marR="73152" marT="27432" marB="27432">
                     <a:lnL w="6350" cap="flat" cmpd="sng" algn="ctr">
                       <a:solidFill>
                         <a:srgbClr val="D5D8D2"/>
@@ -3050,7 +3163,7 @@
                   </a:tcPr>
                 </a:tc>
               </a:tr>
-              <a:tr h="310896">
+              <a:tr h="274320">
                 <a:tc>
                   <a:txBody>
                     <a:bodyPr/>
@@ -3060,7 +3173,7 @@
                         <a:buNone/>
                       </a:pPr>
                       <a:r>
-                        <a:rPr lang="en-US" sz="1000" dirty="0">
+                        <a:rPr lang="en-US" sz="1100" dirty="0">
                           <a:solidFill>
                             <a:srgbClr val="1E2A3A"/>
                           </a:solidFill>
@@ -3070,14 +3183,14 @@
                         </a:rPr>
                         <a:t>Operating profit</a:t>
                       </a:r>
-                      <a:endParaRPr lang="en-US" sz="1000" dirty="0">
+                      <a:endParaRPr lang="en-US" sz="1100" dirty="0">
                         <a:latin typeface="Arial" charset="0"/>
                         <a:ea typeface="Arial" charset="0"/>
                         <a:cs typeface="Arial" charset="0"/>
                       </a:endParaRPr>
                     </a:p>
                   </a:txBody>
-                  <a:tcPr marL="91440" marR="91440" marT="45720" marB="45720">
+                  <a:tcPr marL="73152" marR="73152" marT="27432" marB="27432">
                     <a:lnL w="6350" cap="flat" cmpd="sng" algn="ctr">
                       <a:solidFill>
                         <a:srgbClr val="D5D8D2"/>
@@ -3125,7 +3238,7 @@
                         <a:buNone/>
                       </a:pPr>
                       <a:r>
-                        <a:rPr lang="en-US" sz="1000" dirty="0">
+                        <a:rPr lang="en-US" sz="1100" dirty="0">
                           <a:solidFill>
                             <a:srgbClr val="1E2A3A"/>
                           </a:solidFill>
@@ -3135,14 +3248,14 @@
                         </a:rPr>
                         <a:t>£17,500</a:t>
                       </a:r>
-                      <a:endParaRPr lang="en-US" sz="1000" dirty="0">
+                      <a:endParaRPr lang="en-US" sz="1100" dirty="0">
                         <a:latin typeface="Arial" charset="0"/>
                         <a:ea typeface="Arial" charset="0"/>
                         <a:cs typeface="Arial" charset="0"/>
                       </a:endParaRPr>
                     </a:p>
                   </a:txBody>
-                  <a:tcPr marL="91440" marR="91440" marT="45720" marB="45720">
+                  <a:tcPr marL="73152" marR="73152" marT="27432" marB="27432">
                     <a:lnL w="6350" cap="flat" cmpd="sng" algn="ctr">
                       <a:solidFill>
                         <a:srgbClr val="D5D8D2"/>
@@ -3190,7 +3303,7 @@
                         <a:buNone/>
                       </a:pPr>
                       <a:r>
-                        <a:rPr lang="en-US" sz="1000" dirty="0">
+                        <a:rPr lang="en-US" sz="1100" dirty="0">
                           <a:solidFill>
                             <a:srgbClr val="1E2A3A"/>
                           </a:solidFill>
@@ -3200,14 +3313,14 @@
                         </a:rPr>
                         <a:t>£20,200</a:t>
                       </a:r>
-                      <a:endParaRPr lang="en-US" sz="1000" dirty="0">
+                      <a:endParaRPr lang="en-US" sz="1100" dirty="0">
                         <a:latin typeface="Arial" charset="0"/>
                         <a:ea typeface="Arial" charset="0"/>
                         <a:cs typeface="Arial" charset="0"/>
                       </a:endParaRPr>
                     </a:p>
                   </a:txBody>
-                  <a:tcPr marL="91440" marR="91440" marT="45720" marB="45720">
+                  <a:tcPr marL="73152" marR="73152" marT="27432" marB="27432">
                     <a:lnL w="6350" cap="flat" cmpd="sng" algn="ctr">
                       <a:solidFill>
                         <a:srgbClr val="D5D8D2"/>
@@ -3255,7 +3368,7 @@
                         <a:buNone/>
                       </a:pPr>
                       <a:r>
-                        <a:rPr lang="en-US" sz="1000" dirty="0">
+                        <a:rPr lang="en-US" sz="1100" dirty="0">
                           <a:solidFill>
                             <a:srgbClr val="1E2A3A"/>
                           </a:solidFill>
@@ -3265,14 +3378,14 @@
                         </a:rPr>
                         <a:t>£17,750</a:t>
                       </a:r>
-                      <a:endParaRPr lang="en-US" sz="1000" dirty="0">
+                      <a:endParaRPr lang="en-US" sz="1100" dirty="0">
                         <a:latin typeface="Arial" charset="0"/>
                         <a:ea typeface="Arial" charset="0"/>
                         <a:cs typeface="Arial" charset="0"/>
                       </a:endParaRPr>
                     </a:p>
                   </a:txBody>
-                  <a:tcPr marL="91440" marR="91440" marT="45720" marB="45720">
+                  <a:tcPr marL="73152" marR="73152" marT="27432" marB="27432">
                     <a:lnL w="6350" cap="flat" cmpd="sng" algn="ctr">
                       <a:solidFill>
                         <a:srgbClr val="D5D8D2"/>
@@ -3320,7 +3433,7 @@
                         <a:buNone/>
                       </a:pPr>
                       <a:r>
-                        <a:rPr lang="en-US" sz="1000" dirty="0">
+                        <a:rPr lang="en-US" sz="1100" dirty="0">
                           <a:solidFill>
                             <a:srgbClr val="1E2A3A"/>
                           </a:solidFill>
@@ -3330,14 +3443,14 @@
                         </a:rPr>
                         <a:t>£111,000</a:t>
                       </a:r>
-                      <a:endParaRPr lang="en-US" sz="1000" dirty="0">
+                      <a:endParaRPr lang="en-US" sz="1100" dirty="0">
                         <a:latin typeface="Arial" charset="0"/>
                         <a:ea typeface="Arial" charset="0"/>
                         <a:cs typeface="Arial" charset="0"/>
                       </a:endParaRPr>
                     </a:p>
                   </a:txBody>
-                  <a:tcPr marL="91440" marR="91440" marT="45720" marB="45720">
+                  <a:tcPr marL="73152" marR="73152" marT="27432" marB="27432">
                     <a:lnL w="6350" cap="flat" cmpd="sng" algn="ctr">
                       <a:solidFill>
                         <a:srgbClr val="D5D8D2"/>
@@ -3385,7 +3498,7 @@
                         <a:buNone/>
                       </a:pPr>
                       <a:r>
-                        <a:rPr lang="en-US" sz="1000" dirty="0">
+                        <a:rPr lang="en-US" sz="1100" dirty="0">
                           <a:solidFill>
                             <a:srgbClr val="1E2A3A"/>
                           </a:solidFill>
@@ -3395,14 +3508,14 @@
                         </a:rPr>
                         <a:t>£101,000</a:t>
                       </a:r>
-                      <a:endParaRPr lang="en-US" sz="1000" dirty="0">
+                      <a:endParaRPr lang="en-US" sz="1100" dirty="0">
                         <a:latin typeface="Arial" charset="0"/>
                         <a:ea typeface="Arial" charset="0"/>
                         <a:cs typeface="Arial" charset="0"/>
                       </a:endParaRPr>
                     </a:p>
                   </a:txBody>
-                  <a:tcPr marL="91440" marR="91440" marT="45720" marB="45720">
+                  <a:tcPr marL="73152" marR="73152" marT="27432" marB="27432">
                     <a:lnL w="6350" cap="flat" cmpd="sng" algn="ctr">
                       <a:solidFill>
                         <a:srgbClr val="D5D8D2"/>
@@ -3454,8 +3567,8 @@
         </p:nvSpPr>
         <p:spPr>
           <a:xfrm>
-            <a:off x="548640" y="6263640"/>
-            <a:ext cx="10972800" cy="274320"/>
+            <a:off x="548640" y="6355080"/>
+            <a:ext cx="11064240" cy="274320"/>
           </a:xfrm>
           <a:prstGeom prst="rect">
             <a:avLst/>
@@ -3479,7 +3592,7 @@
                 <a:ea typeface="Arial" pitchFamily="34" charset="-122"/>
                 <a:cs typeface="Arial" pitchFamily="34" charset="-120"/>
               </a:rPr>
-              <a:t>Fictional agency, synthetic data. Prototype layout, not your master template. Released by Reviewer (demo), 3 Sep 2026, text dccd28984bd499a9.</a:t>
+              <a:t>Fictional agency, synthetic data. Prototype layout, not your master template. Released by Reviewer (demo), 3 September 2026, 10:00 UTC, text dccd28984bd499a9.</a:t>
             </a:r>
             <a:endParaRPr lang="en-US" sz="800" dirty="0"/>
           </a:p>

</xml_diff>

<commit_message>
Checker v4 after the ChatGPT 6 Pro verdict: no sentence ticked, each figure marked, all prose accepted by the reviewer; level-as-difference, reversed relations, years and unread words flagged; adverse coverage needs the variance; stamp and headline follow every revocation; two labelled reviewer edits (operating-profit bridge, Marlow & Finch credit note) carried into the export; slide lead lines; real sample release time; fingerprint, payroll, scopes, budget and data wording
</commit_message>
<xml_diff>
--- a/exports/lowther-august-2026-commentary.pptx
+++ b/exports/lowther-august-2026-commentary.pptx
@@ -502,14 +502,16 @@
           <a:p>
             <a:r>
               <a:rPr lang="en-US" dirty="0"/>
-              <a:t>Draft: Draft B, written for the snapshot with the approved accrual (run 2 of 10, claude-sonnet-5, 2026-09-28).
-Figures fingerprint e07356b8a0bce5fe.
+              <a:t>Draft: Draft B, written for the snapshot with the approved accrual (run 2 of 10, claude-sonnet-5, 2026-09-28), with two reviewer edits.
+Figures fingerprint e07356b8a0bce5fe (binds the figures shown, not the source files).
 Evidence, by sentence:
 [1] £200,000 = Revenue, August 2026; report section total; source xero_pl_2026-08.json; metric revenue.month.actual | £10,000 = Revenue, August 2026, difference against budget; actual minus budget; source xero_pl_2026-08.json, xero_budget.json; metric revenue.month.vs_budget | 5.3% = Revenue, August 2026, % change against budget; (actual - budget) / budget; source xero_pl_2026-08.json, xero_budget.json; metric revenue.month.vs_budget_pct | £30,000 = Revenue, August 2026, difference against prior year; actual minus prior year; source xero_pl_2026-08.json, xero_pl_2025-08.json; metric revenue.month.vs_py | 17.6% = Revenue, August 2026, % change against prior year; (actual - prior year) / prior year; source xero_pl_2026-08.json, xero_pl_2025-08.json; metric revenue.month.vs_py_pct | £68,000 = Gross profit, August 2026; revenue £200,000 - direct costs £132,000; source xero_pl_2026-08.json, approved adjustment accrual-aug-payroll; metric gross_profit.month.actual | £4,200 = Gross profit, August 2026, difference against budget; actual minus budget; source approved adjustment accrual-aug-payroll, xero_pl_2026-08.json, xero_budget.json; metric gross_profit.month.vs_budget | 5.8% = Gross profit, August 2026, % change against budget; (actual - budget) / budget; source approved adjustment accrual-aug-payroll, xero_pl_2026-08.json, xero_budget.json; metric gross_profit.month.vs_budget_pct | 34.0% = Gross margin, August 2026; gross profit £68,000 / revenue £200,000; source xero_pl_2026-08.json, approved adjustment accrual-aug-payroll; metric gross_margin.month.actual | 4.0 percentage points = Gross margin, August 2026, difference against budget; actual margin minus budget margin, unrounded; source approved adjustment accrual-aug-payroll, xero_pl_2026-08.json, xero_budget.json; metric gross_margin.month.vs_budget_pp
 [2] £17,500 = Operating profit, August 2026; gross profit £68,000 - overheads £50,500; source xero_pl_2026-08.json, approved adjustment accrual-aug-payroll; metric operating_profit.month.actual | £2,700 = Operating profit, August 2026, difference against budget; actual minus budget; source approved adjustment accrual-aug-payroll, xero_pl_2026-08.json, xero_budget.json; metric operating_profit.month.vs_budget | 13.4% = Operating profit, August 2026, % change against budget; (actual - budget) / budget; source approved adjustment accrual-aug-payroll, xero_pl_2026-08.json, xero_budget.json; metric operating_profit.month.vs_budget_pct | £250 = Operating profit, August 2026, difference against prior year; actual minus prior year; source approved adjustment accrual-aug-payroll, xero_pl_2026-08.json, xero_pl_2025-08.json; metric operating_profit.month.vs_py | 1.4% = Operating profit, August 2026, % change against prior year; (actual - prior year) / prior year; source approved adjustment accrual-aug-payroll, xero_pl_2026-08.json, xero_pl_2025-08.json; metric operating_profit.month.vs_py_pct
-[3] £960,000 = Revenue, year to date, 1 April to 31 August 2026; report section total; source xero_pl_ytd_2026-04_2026-08.json; metric revenue.ytd.actual | £10,000 = Revenue, year to date, 1 April to 31 August 2026, difference against budget; actual minus budget; source xero_pl_ytd_2026-04_2026-08.json, xero_budget.json; metric revenue.ytd.vs_budget | 1.1% = Revenue, year to date, 1 April to 31 August 2026, % change against budget; (actual - budget) / budget; source xero_pl_ytd_2026-04_2026-08.json, xero_budget.json; metric revenue.ytd.vs_budget_pct | £115,000 = Revenue, year to date, 1 April to 31 August 2026, difference against prior year; actual minus prior year; source xero_pl_ytd_2026-04_2026-08.json, xero_pl_ytd_2025-04_2025-08.json; metric revenue.ytd.vs_py | 13.6% = Revenue, year to date, 1 April to 31 August 2026, % change against prior year; (actual - prior year) / prior year; source xero_pl_ytd_2026-04_2026-08.json, xero_pl_ytd_2025-04_2025-08.json; metric revenue.ytd.vs_py_pct | £111,000 = Operating profit, year to date, 1 April to 31 August 2026; gross profit £365,000 - overheads £254,000; source xero_pl_ytd_2026-04_2026-08.json, approved adjustment accrual-aug-payroll; metric operating_profit.ytd.actual | £10,000 = Operating profit, year to date, 1 April to 31 August 2026, difference against budget; actual minus budget; source approved adjustment accrual-aug-payroll, xero_pl_ytd_2026-04_2026-08.json, xero_budget.json; metric operating_profit.ytd.vs_budget | 9.9% = Operating profit, year to date, 1 April to 31 August 2026, % change against budget; (actual - budget) / budget; source approved adjustment accrual-aug-payroll, xero_pl_ytd_2026-04_2026-08.json, xero_budget.json; metric operating_profit.ytd.vs_budget_pct | £34,125 = Operating profit, year to date, 1 April to 31 August 2026, difference against prior year; actual minus prior year; source approved adjustment accrual-aug-payroll, xero_pl_ytd_2026-04_2026-08.json, xero_pl_ytd_2025-04_2025-08.json; metric operating_profit.ytd.vs_py | 44.4% = Operating profit, year to date, 1 April to 31 August 2026, % change against prior year; (actual - prior year) / prior year; source approved adjustment accrual-aug-payroll, xero_pl_ytd_2026-04_2026-08.json, xero_pl_ytd_2025-04_2025-08.json; metric operating_profit.ytd.vs_py_pct
-[4] 31.0% = Orchard Lane Foods: share of agency revenue, August 2026; client revenue / agency revenue; source xero_pl_by_client_2026-08.json, xero_pl_2026-08.json; metric client.orchard-lane.share.month.actual | £62,000 = Orchard Lane Foods: revenue, August 2026; Income, Client column; source xero_pl_by_client_2026-08.json; metric client.orchard-lane.revenue.month.actual | £4,333 = Orchard Lane Foods: revenue, August 2026 against its May to July average, difference; August minus three-month average; source xero_pl_by_client_2026-08.json; metric client.orchard-lane.revenue.month.vs_avg3m | 7.5% = Orchard Lane Foods: revenue, August 2026 against its May to July average, % change; (August - average) / average; source xero_pl_by_client_2026-08.json; metric client.orchard-lane.revenue.month.vs_avg3m_pct
-[5] £18,000 = Marlow &amp; Finch: revenue, August 2026; Income, Client column; source xero_pl_by_client_2026-08.json; metric client.marlow-finch.revenue.month.actual | £12,000 = Marlow &amp; Finch: revenue, August 2026 against its May to July average, difference; August minus three-month average; source xero_pl_by_client_2026-08.json; metric client.marlow-finch.revenue.month.vs_avg3m | 40.0% = Marlow &amp; Finch: revenue, August 2026 against its May to July average, % change; (August - average) / average; source xero_pl_by_client_2026-08.json; metric client.marlow-finch.revenue.month.vs_avg3m_pct | 14.4% = Marlow &amp; Finch: share of agency revenue, year to date; client revenue / agency revenue; source xero_pl_by_client_ytd_2026.json, xero_pl_ytd_2026-04_2026-08.json; metric client.marlow-finch.share.ytd.actual</a:t>
+[3] Reviewer edit. £10,000 = Revenue, August 2026, difference against budget; actual minus budget; source xero_pl_2026-08.json, xero_budget.json; metric revenue.month.vs_budget | £14,200 = Direct costs, August 2026, difference against budget; actual minus budget; source approved adjustment accrual-aug-payroll, xero_pl_2026-08.json, xero_budget.json; metric direct_costs.month.vs_budget | £1,500 = Overheads, August 2026, difference against budget; actual minus budget; source xero_pl_2026-08.json, xero_budget.json; metric overheads.month.vs_budget | £2,700 = Operating profit, August 2026, difference against budget; actual minus budget; source approved adjustment accrual-aug-payroll, xero_pl_2026-08.json, xero_budget.json; metric operating_profit.month.vs_budget
+[4] £960,000 = Revenue, year to date, 1 April to 31 August 2026; report section total; source xero_pl_ytd_2026-04_2026-08.json; metric revenue.ytd.actual | £10,000 = Revenue, year to date, 1 April to 31 August 2026, difference against budget; actual minus budget; source xero_pl_ytd_2026-04_2026-08.json, xero_budget.json; metric revenue.ytd.vs_budget | 1.1% = Revenue, year to date, 1 April to 31 August 2026, % change against budget; (actual - budget) / budget; source xero_pl_ytd_2026-04_2026-08.json, xero_budget.json; metric revenue.ytd.vs_budget_pct | £115,000 = Revenue, year to date, 1 April to 31 August 2026, difference against prior year; actual minus prior year; source xero_pl_ytd_2026-04_2026-08.json, xero_pl_ytd_2025-04_2025-08.json; metric revenue.ytd.vs_py | 13.6% = Revenue, year to date, 1 April to 31 August 2026, % change against prior year; (actual - prior year) / prior year; source xero_pl_ytd_2026-04_2026-08.json, xero_pl_ytd_2025-04_2025-08.json; metric revenue.ytd.vs_py_pct | £111,000 = Operating profit, year to date, 1 April to 31 August 2026; gross profit £365,000 - overheads £254,000; source xero_pl_ytd_2026-04_2026-08.json, approved adjustment accrual-aug-payroll; metric operating_profit.ytd.actual | £10,000 = Operating profit, year to date, 1 April to 31 August 2026, difference against budget; actual minus budget; source approved adjustment accrual-aug-payroll, xero_pl_ytd_2026-04_2026-08.json, xero_budget.json; metric operating_profit.ytd.vs_budget | 9.9% = Operating profit, year to date, 1 April to 31 August 2026, % change against budget; (actual - budget) / budget; source approved adjustment accrual-aug-payroll, xero_pl_ytd_2026-04_2026-08.json, xero_budget.json; metric operating_profit.ytd.vs_budget_pct | £34,125 = Operating profit, year to date, 1 April to 31 August 2026, difference against prior year; actual minus prior year; source approved adjustment accrual-aug-payroll, xero_pl_ytd_2026-04_2026-08.json, xero_pl_ytd_2025-04_2025-08.json; metric operating_profit.ytd.vs_py | 44.4% = Operating profit, year to date, 1 April to 31 August 2026, % change against prior year; (actual - prior year) / prior year; source approved adjustment accrual-aug-payroll, xero_pl_ytd_2026-04_2026-08.json, xero_pl_ytd_2025-04_2025-08.json; metric operating_profit.ytd.vs_py_pct
+[5] 31.0% = Orchard Lane Foods: share of agency revenue, August 2026; client revenue / agency revenue; source xero_pl_by_client_2026-08.json, xero_pl_2026-08.json; metric client.orchard-lane.share.month.actual | £62,000 = Orchard Lane Foods: revenue, August 2026; Income, Client column; source xero_pl_by_client_2026-08.json; metric client.orchard-lane.revenue.month.actual | £4,333 = Orchard Lane Foods: revenue, August 2026 against its May to July average, difference; August minus three-month average; source xero_pl_by_client_2026-08.json; metric client.orchard-lane.revenue.month.vs_avg3m | 7.5% = Orchard Lane Foods: revenue, August 2026 against its May to July average, % change; (August - average) / average; source xero_pl_by_client_2026-08.json; metric client.orchard-lane.revenue.month.vs_avg3m_pct
+[6] Reviewer edit. £18,000 = Marlow &amp; Finch: revenue, August 2026; Income, Client column; source xero_pl_by_client_2026-08.json; metric client.marlow-finch.revenue.month.actual | 40.0% = Marlow &amp; Finch: revenue, August 2026 against its May to July average, % change; (August - average) / average; source xero_pl_by_client_2026-08.json; metric client.marlow-finch.revenue.month.vs_avg3m_pct | £6,000 = Marlow &amp; Finch: credit notes issued in August 2026 (CN-0147); sum of SubTotal of August credit notes; source xero_credit_notes_2026-08.json, xero_pl_by_client_2026-08.json; metric client.marlow-finch.credit_notes.month.actual | £24,000 = Marlow &amp; Finch: revenue, August 2026, excluding its credit notes; client revenue + credit notes; source xero_credit_notes_2026-08.json, xero_pl_by_client_2026-08.json; metric client.marlow-finch.revenue_ex_credit.month.actual | 20.0% = Marlow &amp; Finch: revenue excluding credit notes, August 2026, against its May to July average, % change; (revenue excluding credit notes - average) / average; source xero_credit_notes_2026-08.json, xero_pl_by_client_2026-08.json; metric client.marlow-finch.revenue_ex_credit.month.vs_avg3m_pct
+[7] Reviewer edit. No figure.</a:t>
             </a:r>
             <a:endParaRPr lang="en-US" dirty="0"/>
           </a:p>
@@ -961,8 +963,70 @@
         </p:nvSpPr>
         <p:spPr>
           <a:xfrm>
-            <a:off x="548640" y="1234440"/>
-            <a:ext cx="11064240" cy="2651760"/>
+            <a:off x="548640" y="1188720"/>
+            <a:ext cx="11064240" cy="731520"/>
+          </a:xfrm>
+          <a:prstGeom prst="rect">
+            <a:avLst/>
+          </a:prstGeom>
+          <a:noFill/>
+          <a:ln/>
+        </p:spPr>
+        <p:txBody>
+          <a:bodyPr wrap="square" rtlCol="0" anchor="t"/>
+          <a:lstStyle/>
+          <a:p>
+            <a:pPr indent="0" marL="0">
+              <a:spcAft>
+                <a:spcPts val="400"/>
+              </a:spcAft>
+              <a:buNone/>
+            </a:pPr>
+            <a:r>
+              <a:rPr lang="en-US" sz="1300" b="1" dirty="0">
+                <a:solidFill>
+                  <a:srgbClr val="1E2A3A"/>
+                </a:solidFill>
+                <a:latin typeface="Arial" pitchFamily="34" charset="0"/>
+                <a:ea typeface="Arial" pitchFamily="34" charset="-122"/>
+                <a:cs typeface="Arial" pitchFamily="34" charset="-120"/>
+              </a:rPr>
+              <a:t>Operating profit £17,500, £2,700 below budget: revenue £10,000 above, direct costs £14,200 above, overheads £1,500 below.</a:t>
+            </a:r>
+            <a:endParaRPr lang="en-US" sz="1300" dirty="0"/>
+          </a:p>
+          <a:p>
+            <a:pPr indent="0" marL="0">
+              <a:spcAft>
+                <a:spcPts val="400"/>
+              </a:spcAft>
+              <a:buNone/>
+            </a:pPr>
+            <a:r>
+              <a:rPr lang="en-US" sz="1300" b="1" dirty="0">
+                <a:solidFill>
+                  <a:srgbClr val="1E2A3A"/>
+                </a:solidFill>
+                <a:latin typeface="Arial" pitchFamily="34" charset="0"/>
+                <a:ea typeface="Arial" pitchFamily="34" charset="-122"/>
+                <a:cs typeface="Arial" pitchFamily="34" charset="-120"/>
+              </a:rPr>
+              <a:t>Marlow &amp; Finch £18,000, 40.0% below its May to July average; £6,000 of that is a credit note on July work (excluding it, 20.0% below).</a:t>
+            </a:r>
+            <a:endParaRPr lang="en-US" sz="1300" dirty="0"/>
+          </a:p>
+        </p:txBody>
+      </p:sp>
+      <p:sp>
+        <p:nvSpPr>
+          <p:cNvPr id="5" name="Text 3"/>
+          <p:cNvSpPr/>
+          <p:nvPr/>
+        </p:nvSpPr>
+        <p:spPr>
+          <a:xfrm>
+            <a:off x="548640" y="2011680"/>
+            <a:ext cx="11064240" cy="2331720"/>
           </a:xfrm>
           <a:prstGeom prst="rect">
             <a:avLst/>
@@ -976,15 +1040,15 @@
           <a:p>
             <a:pPr indent="0" marL="0">
               <a:lnSpc>
-                <a:spcPct val="112000"/>
+                <a:spcPct val="110000"/>
               </a:lnSpc>
               <a:spcAft>
-                <a:spcPts val="800"/>
+                <a:spcPts val="600"/>
               </a:spcAft>
               <a:buNone/>
             </a:pPr>
             <a:r>
-              <a:rPr lang="en-US" sz="1200" dirty="0">
+              <a:rPr lang="en-US" sz="1100" dirty="0">
                 <a:solidFill>
                   <a:srgbClr val="1E2A3A"/>
                 </a:solidFill>
@@ -996,15 +1060,15 @@
             </a:r>
             <a:pPr indent="0" marL="0">
               <a:lnSpc>
-                <a:spcPct val="112000"/>
+                <a:spcPct val="110000"/>
               </a:lnSpc>
               <a:spcAft>
-                <a:spcPts val="800"/>
+                <a:spcPts val="600"/>
               </a:spcAft>
               <a:buNone/>
             </a:pPr>
             <a:r>
-              <a:rPr lang="en-US" sz="1200" baseline="30000" dirty="0">
+              <a:rPr lang="en-US" sz="1100" baseline="30000" dirty="0">
                 <a:solidFill>
                   <a:srgbClr val="6B7280"/>
                 </a:solidFill>
@@ -1016,15 +1080,15 @@
             </a:r>
             <a:pPr indent="0" marL="0">
               <a:lnSpc>
-                <a:spcPct val="112000"/>
+                <a:spcPct val="110000"/>
               </a:lnSpc>
               <a:spcAft>
-                <a:spcPts val="800"/>
+                <a:spcPts val="600"/>
               </a:spcAft>
               <a:buNone/>
             </a:pPr>
             <a:r>
-              <a:rPr lang="en-US" sz="1200" dirty="0">
+              <a:rPr lang="en-US" sz="1100" dirty="0">
                 <a:solidFill>
                   <a:srgbClr val="1E2A3A"/>
                 </a:solidFill>
@@ -1036,15 +1100,15 @@
             </a:r>
             <a:pPr indent="0" marL="0">
               <a:lnSpc>
-                <a:spcPct val="112000"/>
+                <a:spcPct val="110000"/>
               </a:lnSpc>
               <a:spcAft>
-                <a:spcPts val="800"/>
+                <a:spcPts val="600"/>
               </a:spcAft>
               <a:buNone/>
             </a:pPr>
             <a:r>
-              <a:rPr lang="en-US" sz="1200" baseline="30000" dirty="0">
+              <a:rPr lang="en-US" sz="1100" baseline="30000" dirty="0">
                 <a:solidFill>
                   <a:srgbClr val="6B7280"/>
                 </a:solidFill>
@@ -1054,20 +1118,60 @@
               </a:rPr>
               <a:t>[2]</a:t>
             </a:r>
-            <a:endParaRPr lang="en-US" sz="1200" dirty="0"/>
+            <a:pPr indent="0" marL="0">
+              <a:lnSpc>
+                <a:spcPct val="110000"/>
+              </a:lnSpc>
+              <a:spcAft>
+                <a:spcPts val="600"/>
+              </a:spcAft>
+              <a:buNone/>
+            </a:pPr>
+            <a:r>
+              <a:rPr lang="en-US" sz="1100" dirty="0">
+                <a:solidFill>
+                  <a:srgbClr val="1E2A3A"/>
+                </a:solidFill>
+                <a:latin typeface="Arial" pitchFamily="34" charset="0"/>
+                <a:ea typeface="Arial" pitchFamily="34" charset="-122"/>
+                <a:cs typeface="Arial" pitchFamily="34" charset="-120"/>
+              </a:rPr>
+              <a:t> Against budget, August revenue was £10,000 higher, but direct costs were £14,200 higher and overheads £1,500 lower, leaving operating profit £2,700 below budget.</a:t>
+            </a:r>
+            <a:pPr indent="0" marL="0">
+              <a:lnSpc>
+                <a:spcPct val="110000"/>
+              </a:lnSpc>
+              <a:spcAft>
+                <a:spcPts val="600"/>
+              </a:spcAft>
+              <a:buNone/>
+            </a:pPr>
+            <a:r>
+              <a:rPr lang="en-US" sz="1100" baseline="30000" dirty="0">
+                <a:solidFill>
+                  <a:srgbClr val="6B7280"/>
+                </a:solidFill>
+                <a:latin typeface="Arial" pitchFamily="34" charset="0"/>
+                <a:ea typeface="Arial" pitchFamily="34" charset="-122"/>
+                <a:cs typeface="Arial" pitchFamily="34" charset="-120"/>
+              </a:rPr>
+              <a:t>[3 R]</a:t>
+            </a:r>
+            <a:endParaRPr lang="en-US" sz="1100" dirty="0"/>
           </a:p>
           <a:p>
             <a:pPr indent="0" marL="0">
               <a:lnSpc>
-                <a:spcPct val="112000"/>
+                <a:spcPct val="110000"/>
               </a:lnSpc>
               <a:spcAft>
-                <a:spcPts val="800"/>
+                <a:spcPts val="600"/>
               </a:spcAft>
               <a:buNone/>
             </a:pPr>
             <a:r>
-              <a:rPr lang="en-US" sz="1200" dirty="0">
+              <a:rPr lang="en-US" sz="1100" dirty="0">
                 <a:solidFill>
                   <a:srgbClr val="1E2A3A"/>
                 </a:solidFill>
@@ -1079,15 +1183,15 @@
             </a:r>
             <a:pPr indent="0" marL="0">
               <a:lnSpc>
-                <a:spcPct val="112000"/>
+                <a:spcPct val="110000"/>
               </a:lnSpc>
               <a:spcAft>
-                <a:spcPts val="800"/>
+                <a:spcPts val="600"/>
               </a:spcAft>
               <a:buNone/>
             </a:pPr>
             <a:r>
-              <a:rPr lang="en-US" sz="1200" baseline="30000" dirty="0">
+              <a:rPr lang="en-US" sz="1100" baseline="30000" dirty="0">
                 <a:solidFill>
                   <a:srgbClr val="6B7280"/>
                 </a:solidFill>
@@ -1095,22 +1199,22 @@
                 <a:ea typeface="Arial" pitchFamily="34" charset="-122"/>
                 <a:cs typeface="Arial" pitchFamily="34" charset="-120"/>
               </a:rPr>
-              <a:t>[3]</a:t>
+              <a:t>[4]</a:t>
             </a:r>
-            <a:endParaRPr lang="en-US" sz="1200" dirty="0"/>
+            <a:endParaRPr lang="en-US" sz="1100" dirty="0"/>
           </a:p>
           <a:p>
             <a:pPr indent="0" marL="0">
               <a:lnSpc>
-                <a:spcPct val="112000"/>
+                <a:spcPct val="110000"/>
               </a:lnSpc>
               <a:spcAft>
-                <a:spcPts val="800"/>
+                <a:spcPts val="600"/>
               </a:spcAft>
               <a:buNone/>
             </a:pPr>
             <a:r>
-              <a:rPr lang="en-US" sz="1200" dirty="0">
+              <a:rPr lang="en-US" sz="1100" dirty="0">
                 <a:solidFill>
                   <a:srgbClr val="1E2A3A"/>
                 </a:solidFill>
@@ -1122,55 +1226,15 @@
             </a:r>
             <a:pPr indent="0" marL="0">
               <a:lnSpc>
-                <a:spcPct val="112000"/>
+                <a:spcPct val="110000"/>
               </a:lnSpc>
               <a:spcAft>
-                <a:spcPts val="800"/>
+                <a:spcPts val="600"/>
               </a:spcAft>
               <a:buNone/>
             </a:pPr>
             <a:r>
-              <a:rPr lang="en-US" sz="1200" baseline="30000" dirty="0">
-                <a:solidFill>
-                  <a:srgbClr val="6B7280"/>
-                </a:solidFill>
-                <a:latin typeface="Arial" pitchFamily="34" charset="0"/>
-                <a:ea typeface="Arial" pitchFamily="34" charset="-122"/>
-                <a:cs typeface="Arial" pitchFamily="34" charset="-120"/>
-              </a:rPr>
-              <a:t>[4]</a:t>
-            </a:r>
-            <a:pPr indent="0" marL="0">
-              <a:lnSpc>
-                <a:spcPct val="112000"/>
-              </a:lnSpc>
-              <a:spcAft>
-                <a:spcPts val="800"/>
-              </a:spcAft>
-              <a:buNone/>
-            </a:pPr>
-            <a:r>
-              <a:rPr lang="en-US" sz="1200" dirty="0">
-                <a:solidFill>
-                  <a:srgbClr val="1E2A3A"/>
-                </a:solidFill>
-                <a:latin typeface="Arial" pitchFamily="34" charset="0"/>
-                <a:ea typeface="Arial" pitchFamily="34" charset="-122"/>
-                <a:cs typeface="Arial" pitchFamily="34" charset="-120"/>
-              </a:rPr>
-              <a:t> Marlow &amp; Finch's August revenue of £18,000 was notably below its May to July average by £12,000 (40.0%), and its share of year-to-date revenue at 14.4% is worth watching alongside the other client movements this month.</a:t>
-            </a:r>
-            <a:pPr indent="0" marL="0">
-              <a:lnSpc>
-                <a:spcPct val="112000"/>
-              </a:lnSpc>
-              <a:spcAft>
-                <a:spcPts val="800"/>
-              </a:spcAft>
-              <a:buNone/>
-            </a:pPr>
-            <a:r>
-              <a:rPr lang="en-US" sz="1200" baseline="30000" dirty="0">
+              <a:rPr lang="en-US" sz="1100" baseline="30000" dirty="0">
                 <a:solidFill>
                   <a:srgbClr val="6B7280"/>
                 </a:solidFill>
@@ -1180,7 +1244,87 @@
               </a:rPr>
               <a:t>[5]</a:t>
             </a:r>
-            <a:endParaRPr lang="en-US" sz="1200" dirty="0"/>
+            <a:pPr indent="0" marL="0">
+              <a:lnSpc>
+                <a:spcPct val="110000"/>
+              </a:lnSpc>
+              <a:spcAft>
+                <a:spcPts val="600"/>
+              </a:spcAft>
+              <a:buNone/>
+            </a:pPr>
+            <a:r>
+              <a:rPr lang="en-US" sz="1100" dirty="0">
+                <a:solidFill>
+                  <a:srgbClr val="1E2A3A"/>
+                </a:solidFill>
+                <a:latin typeface="Arial" pitchFamily="34" charset="0"/>
+                <a:ea typeface="Arial" pitchFamily="34" charset="-122"/>
+                <a:cs typeface="Arial" pitchFamily="34" charset="-120"/>
+              </a:rPr>
+              <a:t> Marlow &amp; Finch's August revenue of £18,000 was 40.0% below its May to July average; it includes a credit note of £6,000 for July work, and excluding it, August revenue was £24,000, 20.0% below its May to July average.</a:t>
+            </a:r>
+            <a:pPr indent="0" marL="0">
+              <a:lnSpc>
+                <a:spcPct val="110000"/>
+              </a:lnSpc>
+              <a:spcAft>
+                <a:spcPts val="600"/>
+              </a:spcAft>
+              <a:buNone/>
+            </a:pPr>
+            <a:r>
+              <a:rPr lang="en-US" sz="1100" baseline="30000" dirty="0">
+                <a:solidFill>
+                  <a:srgbClr val="6B7280"/>
+                </a:solidFill>
+                <a:latin typeface="Arial" pitchFamily="34" charset="0"/>
+                <a:ea typeface="Arial" pitchFamily="34" charset="-122"/>
+                <a:cs typeface="Arial" pitchFamily="34" charset="-120"/>
+              </a:rPr>
+              <a:t>[6 R]</a:t>
+            </a:r>
+            <a:pPr indent="0" marL="0">
+              <a:lnSpc>
+                <a:spcPct val="110000"/>
+              </a:lnSpc>
+              <a:spcAft>
+                <a:spcPts val="600"/>
+              </a:spcAft>
+              <a:buNone/>
+            </a:pPr>
+            <a:r>
+              <a:rPr lang="en-US" sz="1100" dirty="0">
+                <a:solidFill>
+                  <a:srgbClr val="1E2A3A"/>
+                </a:solidFill>
+                <a:latin typeface="Arial" pitchFamily="34" charset="0"/>
+                <a:ea typeface="Arial" pitchFamily="34" charset="-122"/>
+                <a:cs typeface="Arial" pitchFamily="34" charset="-120"/>
+              </a:rPr>
+              <a:t> The rest of the fall is to be confirmed with the account lead.</a:t>
+            </a:r>
+            <a:pPr indent="0" marL="0">
+              <a:lnSpc>
+                <a:spcPct val="110000"/>
+              </a:lnSpc>
+              <a:spcAft>
+                <a:spcPts val="600"/>
+              </a:spcAft>
+              <a:buNone/>
+            </a:pPr>
+            <a:r>
+              <a:rPr lang="en-US" sz="1100" baseline="30000" dirty="0">
+                <a:solidFill>
+                  <a:srgbClr val="6B7280"/>
+                </a:solidFill>
+                <a:latin typeface="Arial" pitchFamily="34" charset="0"/>
+                <a:ea typeface="Arial" pitchFamily="34" charset="-122"/>
+                <a:cs typeface="Arial" pitchFamily="34" charset="-120"/>
+              </a:rPr>
+              <a:t>[7 R]</a:t>
+            </a:r>
+            <a:endParaRPr lang="en-US" sz="1100" dirty="0"/>
           </a:p>
         </p:txBody>
       </p:sp>
@@ -1199,7 +1343,7 @@
           </p:nvPr>
         </p:nvGraphicFramePr>
         <p:xfrm>
-          <a:off x="548640" y="4069080"/>
+          <a:off x="548640" y="4434840"/>
           <a:ext cx="11064240" cy="914400"/>
         </p:xfrm>
         <a:graphic>
@@ -3561,7 +3705,7 @@
       </p:graphicFrame>
       <p:sp>
         <p:nvSpPr>
-          <p:cNvPr id="6" name="Text 3"/>
+          <p:cNvPr id="7" name="Text 4"/>
           <p:cNvSpPr/>
           <p:nvPr/>
         </p:nvSpPr>
@@ -3592,7 +3736,7 @@
                 <a:ea typeface="Arial" pitchFamily="34" charset="-122"/>
                 <a:cs typeface="Arial" pitchFamily="34" charset="-120"/>
               </a:rPr>
-              <a:t>Fictional agency, synthetic data. Prototype layout, not your master template. Released by Reviewer (demo), 3 September 2026, 10:00 UTC, text dccd28984bd499a9.</a:t>
+              <a:t>Fictional agency, synthetic data. Prototype layout, not your master template. R: reviewer edit (sentences 3, 6, 7); other sentences as Claude wrote them. Released by Reviewer (demo), 28 September 2026, 14:46 UTC, text abdae08bd6df7d34.</a:t>
             </a:r>
             <a:endParaRPr lang="en-US" sz="800" dirty="0"/>
           </a:p>

</xml_diff>